<commit_message>
Make construction proposal general and remove dashboard slide
Remove 'for discussion' and client-specific wording, drop the prepared-for
line, describe construction companies in general, relabel modules as
core/supporting, replace the dashboard mock-up with a reports overview
and remove the free-support item.

Co-Authored-By: Claude Opus 5.5 <noreply@anthropic.com>
Claude-Session: https://claude.ai/code/session_01JN1xXW5sGZrcbeUUaddYi7
</commit_message>
<xml_diff>
--- a/docs/proposals/Construction_Management_System_Proposal.pptx
+++ b/docs/proposals/Construction_Management_System_Proposal.pptx
@@ -126,271 +126,6 @@
 </p:presentation>
 </file>
 
-<file path=ppt/charts/chart1.xml><?xml version="1.0" encoding="utf-8"?>
-<c:chartSpace xmlns:c="http://schemas.openxmlformats.org/drawingml/2006/chart" xmlns:a="http://schemas.openxmlformats.org/drawingml/2006/main" xmlns:r="http://schemas.openxmlformats.org/officeDocument/2006/relationships">
-  <c:date1904 val="0"/>
-  <c:roundedCorners val="1"/>
-  <c:chart>
-    <c:title>
-      <c:tx>
-        <c:rich>
-          <a:bodyPr/>
-          <a:lstStyle/>
-          <a:p>
-            <a:pPr>
-              <a:defRPr sz="1100" b="0" i="0" u="none" strike="noStrike">
-                <a:solidFill>
-                  <a:srgbClr val="1E2226"/>
-                </a:solidFill>
-                <a:latin typeface="Arial"/>
-              </a:defRPr>
-            </a:pPr>
-            <a:r>
-              <a:rPr sz="1100" b="0" i="0" u="none" strike="noStrike">
-                <a:solidFill>
-                  <a:srgbClr val="1E2226"/>
-                </a:solidFill>
-                <a:latin typeface="Arial"/>
-              </a:rPr>
-              <a:t>Progress by building (%)</a:t>
-            </a:r>
-          </a:p>
-        </c:rich>
-      </c:tx>
-      <c:layout/>
-      <c:overlay val="0"/>
-    </c:title>
-    <c:autoTitleDeleted val="0"/>
-    <c:plotArea>
-      <c:layout/>
-      <c:barChart>
-        <c:barDir val="bar"/>
-        <c:grouping val="clustered"/>
-        <c:varyColors val="0"/>
-        <c:ser>
-          <c:idx val="0"/>
-          <c:order val="0"/>
-          <c:tx>
-            <c:strRef>
-              <c:f>Sheet1!$B$1</c:f>
-              <c:strCache>
-                <c:ptCount val="1"/>
-                <c:pt idx="0">
-                  <c:v>Progress</c:v>
-                </c:pt>
-              </c:strCache>
-            </c:strRef>
-          </c:tx>
-          <c:spPr>
-            <a:solidFill>
-              <a:srgbClr val="E8590C"/>
-            </a:solidFill>
-            <a:effectLst/>
-          </c:spPr>
-          <c:invertIfNegative val="0"/>
-          <c:dLbls>
-            <c:numFmt formatCode="#,##0" sourceLinked="0"/>
-            <c:txPr>
-              <a:bodyPr/>
-              <a:lstStyle/>
-              <a:p>
-                <a:pPr>
-                  <a:defRPr b="0" i="0" strike="noStrike" sz="1000" u="none">
-                    <a:solidFill>
-                      <a:srgbClr val="23272B"/>
-                    </a:solidFill>
-                    <a:latin typeface="Arial"/>
-                  </a:defRPr>
-                </a:pPr>
-              </a:p>
-            </c:txPr>
-            <c:showLegendKey val="0"/>
-            <c:showVal val="1"/>
-            <c:showCatName val="0"/>
-            <c:showSerName val="0"/>
-            <c:showPercent val="0"/>
-            <c:showBubbleSize val="0"/>
-            <c:showLeaderLines val="0"/>
-          </c:dLbls>
-          <c:cat>
-            <c:multiLvlStrRef>
-              <c:f>Sheet1!$A$2:$A$5</c:f>
-              <c:multiLvlStrCache>
-                <c:ptCount val="4"/>
-                <c:lvl>
-                  <c:pt idx="0">
-                    <c:v>Bole G+7</c:v>
-                  </c:pt>
-                  <c:pt idx="1">
-                    <c:v>CMC G+5</c:v>
-                  </c:pt>
-                  <c:pt idx="2">
-                    <c:v>Ayat G+9</c:v>
-                  </c:pt>
-                  <c:pt idx="3">
-                    <c:v>Summit G+6</c:v>
-                  </c:pt>
-                </c:lvl>
-              </c:multiLvlStrCache>
-            </c:multiLvlStrRef>
-          </c:cat>
-          <c:val>
-            <c:numRef>
-              <c:f>Sheet1!$B$2:$B$5</c:f>
-              <c:numCache>
-                <c:formatCode>General</c:formatCode>
-                <c:ptCount val="4"/>
-                <c:pt idx="0">
-                  <c:v>72</c:v>
-                </c:pt>
-                <c:pt idx="1">
-                  <c:v>45</c:v>
-                </c:pt>
-                <c:pt idx="2">
-                  <c:v>18</c:v>
-                </c:pt>
-                <c:pt idx="3">
-                  <c:v>90</c:v>
-                </c:pt>
-              </c:numCache>
-            </c:numRef>
-          </c:val>
-        </c:ser>
-        <c:dLbls>
-          <c:numFmt formatCode="#,##0" sourceLinked="0"/>
-          <c:txPr>
-            <a:bodyPr/>
-            <a:lstStyle/>
-            <a:p>
-              <a:pPr>
-                <a:defRPr b="0" i="0" strike="noStrike" sz="1000" u="none">
-                  <a:solidFill>
-                    <a:srgbClr val="23272B"/>
-                  </a:solidFill>
-                  <a:latin typeface="Arial"/>
-                </a:defRPr>
-              </a:pPr>
-            </a:p>
-          </c:txPr>
-          <c:showLegendKey val="0"/>
-          <c:showVal val="1"/>
-          <c:showCatName val="0"/>
-          <c:showSerName val="0"/>
-          <c:showPercent val="0"/>
-          <c:showBubbleSize val="0"/>
-          <c:showLeaderLines val="0"/>
-        </c:dLbls>
-        <c:gapWidth val="60"/>
-        <c:overlap val="0"/>
-        <c:axId val="2094734554"/>
-        <c:axId val="2094734552"/>
-        <c:axId val="2094734556"/>
-      </c:barChart>
-      <c:catAx>
-        <c:axId val="2094734554"/>
-        <c:scaling>
-          <c:orientation val="maxMin"/>
-        </c:scaling>
-        <c:delete val="0"/>
-        <c:axPos val="l"/>
-        <c:numFmt formatCode="General" sourceLinked="1"/>
-        <c:majorTickMark val="out"/>
-        <c:minorTickMark val="none"/>
-        <c:tickLblPos val="nextTo"/>
-        <c:spPr>
-          <a:ln w="12700" cap="flat">
-            <a:solidFill>
-              <a:srgbClr val="888888"/>
-            </a:solidFill>
-            <a:prstDash val="solid"/>
-            <a:round/>
-          </a:ln>
-        </c:spPr>
-        <c:txPr>
-          <a:bodyPr/>
-          <a:lstStyle/>
-          <a:p>
-            <a:pPr>
-              <a:defRPr sz="1000" b="0" i="0" u="none" strike="noStrike">
-                <a:solidFill>
-                  <a:srgbClr val="23272B"/>
-                </a:solidFill>
-                <a:latin typeface="Arial"/>
-              </a:defRPr>
-            </a:pPr>
-            <a:endParaRPr lang="en-US"/>
-          </a:p>
-        </c:txPr>
-        <c:crossAx val="2094734552"/>
-        <c:crosses val="autoZero"/>
-        <c:auto val="1"/>
-        <c:lblAlgn val="ctr"/>
-        <c:noMultiLvlLbl val="1"/>
-      </c:catAx>
-      <c:valAx>
-        <c:axId val="2094734552"/>
-        <c:scaling>
-          <c:orientation val="minMax"/>
-          <c:max val="100"/>
-        </c:scaling>
-        <c:delete val="1"/>
-        <c:axPos val="b"/>
-        <c:numFmt formatCode="General" sourceLinked="0"/>
-        <c:majorTickMark val="out"/>
-        <c:minorTickMark val="none"/>
-        <c:tickLblPos val="low"/>
-        <c:spPr>
-          <a:ln w="12700" cap="flat">
-            <a:solidFill>
-              <a:srgbClr val="888888"/>
-            </a:solidFill>
-            <a:prstDash val="solid"/>
-            <a:round/>
-          </a:ln>
-        </c:spPr>
-        <c:txPr>
-          <a:bodyPr/>
-          <a:lstStyle/>
-          <a:p>
-            <a:pPr>
-              <a:defRPr sz="1200" b="0" i="0" u="none" strike="noStrike">
-                <a:solidFill>
-                  <a:srgbClr val="000000"/>
-                </a:solidFill>
-                <a:latin typeface="Arial"/>
-              </a:defRPr>
-            </a:pPr>
-            <a:endParaRPr lang="en-US"/>
-          </a:p>
-        </c:txPr>
-        <c:crossAx val="2094734554"/>
-        <c:crosses val="autoZero"/>
-        <c:crossBetween val="between"/>
-      </c:valAx>
-      <c:spPr>
-        <a:noFill/>
-        <a:ln>
-          <a:noFill/>
-        </a:ln>
-        <a:effectLst/>
-      </c:spPr>
-    </c:plotArea>
-    <c:plotVisOnly val="1"/>
-    <c:dispBlanksAs val="span"/>
-  </c:chart>
-  <c:spPr>
-    <a:noFill/>
-    <a:ln>
-      <a:noFill/>
-    </a:ln>
-    <a:effectLst/>
-  </c:spPr>
-  <c:externalData r:id="rId1">
-    <c:autoUpdate val="0"/>
-  </c:externalData>
-</c:chartSpace>
-</file>
-
 <file path=ppt/notesMasters/notesMaster1.xml><?xml version="1.0" encoding="utf-8"?>
 <p:notesMaster xmlns:a="http://schemas.openxmlformats.org/drawingml/2006/main" xmlns:r="http://schemas.openxmlformats.org/officeDocument/2006/relationships" xmlns:p="http://schemas.openxmlformats.org/presentationml/2006/main">
   <p:cSld>
@@ -786,7 +521,7 @@
           <a:p>
             <a:r>
               <a:rPr lang="en-US" dirty="0"/>
-              <a:t>This is a proposal for discussion. The owner asked us to research the construction business and propose a complete system, then add anything we missed together.</a:t>
+              <a:t>A complete system proposal for a construction company. Anything the client needs beyond this can be added to the scope.</a:t>
             </a:r>
             <a:endParaRPr lang="en-US" dirty="0"/>
           </a:p>
@@ -1050,7 +785,7 @@
           <a:p>
             <a:r>
               <a:rPr lang="en-US" dirty="0"/>
-              <a:t>Mock-up only. Ask the owner which figures he wants to see first thing every morning.</a:t>
+              <a:t>Additional reports can be added during the requirements step.</a:t>
             </a:r>
             <a:endParaRPr lang="en-US" dirty="0"/>
           </a:p>
@@ -1754,7 +1489,7 @@
           <a:p>
             <a:r>
               <a:rPr lang="en-US" dirty="0"/>
-              <a:t>Confirm this summary with the owner first. Ask how many sites run at the same time and roughly how many daily workers.</a:t>
+              <a:t>A general picture of how building contractors work. The system is built around these five core departments.</a:t>
             </a:r>
             <a:endParaRPr lang="en-US" dirty="0"/>
           </a:p>
@@ -2458,7 +2193,7 @@
           <a:p>
             <a:r>
               <a:rPr lang="en-US" dirty="0"/>
-              <a:t>Ask the owner what is missing from Finance &amp; receipts and Client billing. Anything he adds goes into the final scope.</a:t>
+              <a:t>Ask the owner what is missing from Finance and Client billing. Anything he adds goes into the final scope.</a:t>
             </a:r>
             <a:endParaRPr lang="en-US" dirty="0"/>
           </a:p>
@@ -3314,7 +3049,7 @@
                 <a:ea typeface="Arial" pitchFamily="34" charset="-122"/>
                 <a:cs typeface="Arial" pitchFamily="34" charset="-120"/>
               </a:rPr>
-              <a:t>SYSTEM PROPOSAL FOR DISCUSSION</a:t>
+              <a:t>SYSTEM PROPOSAL</a:t>
             </a:r>
             <a:endParaRPr lang="en-US" sz="1300" dirty="0"/>
           </a:p>
@@ -3392,7 +3127,7 @@
                 <a:ea typeface="Arial" pitchFamily="34" charset="-122"/>
                 <a:cs typeface="Arial" pitchFamily="34" charset="-120"/>
               </a:rPr>
-              <a:t>One web system for projects and sites, market prices and sales, finance with receipts, HR and daily workers, and stock</a:t>
+              <a:t>One web system for projects and sites, market prices and sales, finance, HR and daily workers, and stock</a:t>
             </a:r>
             <a:endParaRPr lang="en-US" sz="1700" dirty="0"/>
           </a:p>
@@ -3407,54 +3142,17 @@
         <p:spPr>
           <a:xfrm>
             <a:off x="731520" y="4434840"/>
-            <a:ext cx="6858000" cy="1005840"/>
-          </a:xfrm>
-          <a:prstGeom prst="rect">
-            <a:avLst/>
-          </a:prstGeom>
-          <a:noFill/>
-          <a:ln/>
-        </p:spPr>
-        <p:txBody>
-          <a:bodyPr wrap="square" lIns="0" tIns="0" rIns="0" bIns="0" rtlCol="0" anchor="ctr"/>
-          <a:lstStyle/>
-          <a:p>
-            <a:pPr indent="0" marL="0">
-              <a:spcAft>
-                <a:spcPts val="400"/>
-              </a:spcAft>
-              <a:buNone/>
-            </a:pPr>
-            <a:r>
-              <a:rPr lang="en-US" sz="1300" dirty="0">
-                <a:solidFill>
-                  <a:srgbClr val="8A929B"/>
-                </a:solidFill>
-                <a:latin typeface="Arial" pitchFamily="34" charset="0"/>
-                <a:ea typeface="Arial" pitchFamily="34" charset="-122"/>
-                <a:cs typeface="Arial" pitchFamily="34" charset="-120"/>
-              </a:rPr>
-              <a:t>Prepared for  </a:t>
-            </a:r>
-            <a:pPr indent="0" marL="0">
-              <a:spcAft>
-                <a:spcPts val="400"/>
-              </a:spcAft>
-              <a:buNone/>
-            </a:pPr>
-            <a:r>
-              <a:rPr lang="en-US" sz="1300" b="1" dirty="0">
-                <a:solidFill>
-                  <a:srgbClr val="FFFFFF"/>
-                </a:solidFill>
-                <a:latin typeface="Arial" pitchFamily="34" charset="0"/>
-                <a:ea typeface="Arial" pitchFamily="34" charset="-122"/>
-                <a:cs typeface="Arial" pitchFamily="34" charset="-120"/>
-              </a:rPr>
-              <a:t>[Company Name] Construction</a:t>
-            </a:r>
-            <a:endParaRPr lang="en-US" sz="1300" dirty="0"/>
-          </a:p>
+            <a:ext cx="6858000" cy="731520"/>
+          </a:xfrm>
+          <a:prstGeom prst="rect">
+            <a:avLst/>
+          </a:prstGeom>
+          <a:noFill/>
+          <a:ln/>
+        </p:spPr>
+        <p:txBody>
+          <a:bodyPr wrap="square" lIns="0" tIns="0" rIns="0" bIns="0" rtlCol="0" anchor="ctr"/>
+          <a:lstStyle/>
           <a:p>
             <a:pPr indent="0" marL="0">
               <a:spcAft>
@@ -3929,7 +3627,7 @@
                 <a:ea typeface="Arial" pitchFamily="34" charset="-122"/>
                 <a:cs typeface="Arial" pitchFamily="34" charset="-120"/>
               </a:rPr>
-              <a:t>FROM YOUR DEPARTMENTS</a:t>
+              <a:t>CORE MODULE</a:t>
             </a:r>
             <a:endParaRPr lang="en-US" sz="950" dirty="0"/>
           </a:p>
@@ -4268,7 +3966,7 @@
                 <a:ea typeface="Arial" pitchFamily="34" charset="-122"/>
                 <a:cs typeface="Arial" pitchFamily="34" charset="-120"/>
               </a:rPr>
-              <a:t>ADDED BY US</a:t>
+              <a:t>SUPPORTING MODULE</a:t>
             </a:r>
             <a:endParaRPr lang="en-US" sz="950" dirty="0"/>
           </a:p>
@@ -4884,7 +4582,7 @@
                 <a:ea typeface="Arial" pitchFamily="34" charset="-122"/>
                 <a:cs typeface="Arial" pitchFamily="34" charset="-120"/>
               </a:rPr>
-              <a:t>ADDED BY US</a:t>
+              <a:t>SUPPORTING MODULE</a:t>
             </a:r>
             <a:endParaRPr lang="en-US" sz="950" dirty="0"/>
           </a:p>
@@ -5223,7 +4921,7 @@
                 <a:ea typeface="Arial" pitchFamily="34" charset="-122"/>
                 <a:cs typeface="Arial" pitchFamily="34" charset="-120"/>
               </a:rPr>
-              <a:t>ADDED BY US</a:t>
+              <a:t>SUPPORTING MODULE</a:t>
             </a:r>
             <a:endParaRPr lang="en-US" sz="950" dirty="0"/>
           </a:p>
@@ -5531,7 +5229,7 @@
                 <a:ea typeface="Arial" pitchFamily="34" charset="-122"/>
                 <a:cs typeface="Arial" pitchFamily="34" charset="-120"/>
               </a:rPr>
-              <a:t>05 · OWNER DASHBOARD</a:t>
+              <a:t>05 · REPORTS</a:t>
             </a:r>
             <a:endParaRPr lang="en-US" sz="1100" dirty="0"/>
           </a:p>
@@ -5570,7 +5268,7 @@
                 <a:ea typeface="Arial" pitchFamily="34" charset="-122"/>
                 <a:cs typeface="Arial" pitchFamily="34" charset="-120"/>
               </a:rPr>
-              <a:t>What the owner sees on one screen</a:t>
+              <a:t>Reports the system produces</a:t>
             </a:r>
             <a:endParaRPr lang="en-US" sz="2800" dirty="0"/>
           </a:p>
@@ -5609,7 +5307,7 @@
                 <a:ea typeface="Arial" pitchFamily="34" charset="-122"/>
                 <a:cs typeface="Arial" pitchFamily="34" charset="-120"/>
               </a:rPr>
-              <a:t>Illustrative only; all figures are sample data</a:t>
+              <a:t>Ready at any time, filtered by building, site, period or person, and exported to Excel or PDF</a:t>
             </a:r>
             <a:endParaRPr lang="en-US" sz="1400" dirty="0"/>
           </a:p>
@@ -5726,97 +5424,8 @@
         </p:nvSpPr>
         <p:spPr>
           <a:xfrm>
-            <a:off x="548640" y="1737360"/>
-            <a:ext cx="11064240" cy="4572000"/>
-          </a:xfrm>
-          <a:prstGeom prst="rect">
-            <a:avLst/>
-          </a:prstGeom>
-          <a:solidFill>
-            <a:srgbClr val="FFFFFF"/>
-          </a:solidFill>
-          <a:ln w="12700">
-            <a:solidFill>
-              <a:srgbClr val="D9DCE0"/>
-            </a:solidFill>
-            <a:prstDash val="solid"/>
-          </a:ln>
-        </p:spPr>
-      </p:sp>
-      <p:sp>
-        <p:nvSpPr>
-          <p:cNvPr id="10" name="Shape 8"/>
-          <p:cNvSpPr/>
-          <p:nvPr/>
-        </p:nvSpPr>
-        <p:spPr>
-          <a:xfrm>
-            <a:off x="548640" y="1737360"/>
-            <a:ext cx="11064240" cy="329184"/>
-          </a:xfrm>
-          <a:prstGeom prst="rect">
-            <a:avLst/>
-          </a:prstGeom>
-          <a:solidFill>
-            <a:srgbClr val="1E2226"/>
-          </a:solidFill>
-          <a:ln w="12700">
-            <a:solidFill>
-              <a:srgbClr val="1E2226"/>
-            </a:solidFill>
-            <a:prstDash val="solid"/>
-          </a:ln>
-        </p:spPr>
-      </p:sp>
-      <p:sp>
-        <p:nvSpPr>
-          <p:cNvPr id="11" name="Text 9"/>
-          <p:cNvSpPr txBox="1"/>
-          <p:nvPr/>
-        </p:nvSpPr>
-        <p:spPr>
-          <a:xfrm>
-            <a:off x="731520" y="1737360"/>
-            <a:ext cx="4572000" cy="329184"/>
-          </a:xfrm>
-          <a:prstGeom prst="rect">
-            <a:avLst/>
-          </a:prstGeom>
-          <a:noFill/>
-          <a:ln/>
-        </p:spPr>
-        <p:txBody>
-          <a:bodyPr wrap="square" lIns="0" tIns="0" rIns="0" bIns="0" rtlCol="0" anchor="ctr"/>
-          <a:lstStyle/>
-          <a:p>
-            <a:pPr indent="0" marL="0">
-              <a:buNone/>
-            </a:pPr>
-            <a:r>
-              <a:rPr lang="en-US" sz="1000" dirty="0">
-                <a:solidFill>
-                  <a:srgbClr val="B8BEC6"/>
-                </a:solidFill>
-                <a:latin typeface="Arial" pitchFamily="34" charset="0"/>
-                <a:ea typeface="Arial" pitchFamily="34" charset="-122"/>
-                <a:cs typeface="Arial" pitchFamily="34" charset="-120"/>
-              </a:rPr>
-              <a:t>cms.company.com / dashboard</a:t>
-            </a:r>
-            <a:endParaRPr lang="en-US" sz="1000" dirty="0"/>
-          </a:p>
-        </p:txBody>
-      </p:sp>
-      <p:sp>
-        <p:nvSpPr>
-          <p:cNvPr id="12" name="Shape 10"/>
-          <p:cNvSpPr/>
-          <p:nvPr/>
-        </p:nvSpPr>
-        <p:spPr>
-          <a:xfrm>
-            <a:off x="548640" y="2066544"/>
-            <a:ext cx="1920240" cy="4242816"/>
+            <a:off x="548640" y="1783080"/>
+            <a:ext cx="3566160" cy="2057400"/>
           </a:xfrm>
           <a:prstGeom prst="rect">
             <a:avLst/>
@@ -5834,14 +5443,14 @@
       </p:sp>
       <p:sp>
         <p:nvSpPr>
-          <p:cNvPr id="13" name="Shape 11"/>
+          <p:cNvPr id="10" name="Shape 8"/>
           <p:cNvSpPr/>
           <p:nvPr/>
         </p:nvSpPr>
         <p:spPr>
           <a:xfrm>
-            <a:off x="548640" y="2167128"/>
-            <a:ext cx="1920240" cy="310896"/>
+            <a:off x="548640" y="1783080"/>
+            <a:ext cx="566928" cy="566928"/>
           </a:xfrm>
           <a:prstGeom prst="rect">
             <a:avLst/>
@@ -5857,16 +5466,40 @@
           </a:ln>
         </p:spPr>
       </p:sp>
-      <p:sp>
-        <p:nvSpPr>
-          <p:cNvPr id="14" name="Text 12"/>
-          <p:cNvSpPr txBox="1"/>
-          <p:nvPr/>
-        </p:nvSpPr>
-        <p:spPr>
-          <a:xfrm>
-            <a:off x="777240" y="2194560"/>
-            <a:ext cx="1645920" cy="256032"/>
+      <p:pic>
+        <p:nvPicPr>
+          <p:cNvPr id="11" name="Image 0" descr="preencoded.png">    </p:cNvPr>
+          <p:cNvPicPr>
+            <a:picLocks noChangeAspect="1"/>
+          </p:cNvPicPr>
+          <p:nvPr/>
+        </p:nvPicPr>
+        <p:blipFill>
+          <a:blip r:embed="rId1"/>
+          <a:stretch>
+            <a:fillRect/>
+          </a:stretch>
+        </p:blipFill>
+        <p:spPr>
+          <a:xfrm>
+            <a:off x="673364" y="1907804"/>
+            <a:ext cx="317480" cy="317480"/>
+          </a:xfrm>
+          <a:prstGeom prst="rect">
+            <a:avLst/>
+          </a:prstGeom>
+        </p:spPr>
+      </p:pic>
+      <p:sp>
+        <p:nvSpPr>
+          <p:cNvPr id="12" name="Text 9"/>
+          <p:cNvSpPr txBox="1"/>
+          <p:nvPr/>
+        </p:nvSpPr>
+        <p:spPr>
+          <a:xfrm>
+            <a:off x="1280160" y="1783080"/>
+            <a:ext cx="2743200" cy="566928"/>
           </a:xfrm>
           <a:prstGeom prst="rect">
             <a:avLst/>
@@ -5882,46 +5515,50 @@
               <a:buNone/>
             </a:pPr>
             <a:r>
-              <a:rPr lang="en-US" sz="1050" b="1" dirty="0">
-                <a:solidFill>
-                  <a:srgbClr val="FFFFFF"/>
-                </a:solidFill>
-                <a:latin typeface="Arial" pitchFamily="34" charset="0"/>
-                <a:ea typeface="Arial" pitchFamily="34" charset="-122"/>
-                <a:cs typeface="Arial" pitchFamily="34" charset="-120"/>
-              </a:rPr>
-              <a:t>Dashboard</a:t>
-            </a:r>
-            <a:endParaRPr lang="en-US" sz="1050" dirty="0"/>
-          </a:p>
-        </p:txBody>
-      </p:sp>
-      <p:sp>
-        <p:nvSpPr>
-          <p:cNvPr id="15" name="Text 13"/>
-          <p:cNvSpPr txBox="1"/>
-          <p:nvPr/>
-        </p:nvSpPr>
-        <p:spPr>
-          <a:xfrm>
-            <a:off x="777240" y="2560320"/>
-            <a:ext cx="1645920" cy="256032"/>
-          </a:xfrm>
-          <a:prstGeom prst="rect">
-            <a:avLst/>
-          </a:prstGeom>
-          <a:noFill/>
-          <a:ln/>
-        </p:spPr>
-        <p:txBody>
-          <a:bodyPr wrap="square" lIns="0" tIns="0" rIns="0" bIns="0" rtlCol="0" anchor="ctr"/>
-          <a:lstStyle/>
-          <a:p>
-            <a:pPr indent="0" marL="0">
-              <a:buNone/>
-            </a:pPr>
-            <a:r>
-              <a:rPr lang="en-US" sz="1050" dirty="0">
+              <a:rPr lang="en-US" sz="1500" b="1" dirty="0">
+                <a:solidFill>
+                  <a:srgbClr val="1E2226"/>
+                </a:solidFill>
+                <a:latin typeface="Arial" pitchFamily="34" charset="0"/>
+                <a:ea typeface="Arial" pitchFamily="34" charset="-122"/>
+                <a:cs typeface="Arial" pitchFamily="34" charset="-120"/>
+              </a:rPr>
+              <a:t>Projects &amp; sites</a:t>
+            </a:r>
+            <a:endParaRPr lang="en-US" sz="1500" dirty="0"/>
+          </a:p>
+        </p:txBody>
+      </p:sp>
+      <p:sp>
+        <p:nvSpPr>
+          <p:cNvPr id="13" name="Text 10"/>
+          <p:cNvSpPr txBox="1"/>
+          <p:nvPr/>
+        </p:nvSpPr>
+        <p:spPr>
+          <a:xfrm>
+            <a:off x="777240" y="2514600"/>
+            <a:ext cx="3154680" cy="1234440"/>
+          </a:xfrm>
+          <a:prstGeom prst="rect">
+            <a:avLst/>
+          </a:prstGeom>
+          <a:noFill/>
+          <a:ln/>
+        </p:spPr>
+        <p:txBody>
+          <a:bodyPr wrap="square" lIns="0" tIns="0" rIns="0" bIns="0" rtlCol="0" anchor="t"/>
+          <a:lstStyle/>
+          <a:p>
+            <a:pPr marL="177800" indent="-177800">
+              <a:spcAft>
+                <a:spcPts val="400"/>
+              </a:spcAft>
+              <a:buSzPct val="100000"/>
+              <a:buChar char="•"/>
+            </a:pPr>
+            <a:r>
+              <a:rPr lang="en-US" sz="1250" dirty="0">
                 <a:solidFill>
                   <a:srgbClr val="23272B"/>
                 </a:solidFill>
@@ -5929,38 +5566,20 @@
                 <a:ea typeface="Arial" pitchFamily="34" charset="-122"/>
                 <a:cs typeface="Arial" pitchFamily="34" charset="-120"/>
               </a:rPr>
-              <a:t>Projects</a:t>
-            </a:r>
-            <a:endParaRPr lang="en-US" sz="1050" dirty="0"/>
-          </a:p>
-        </p:txBody>
-      </p:sp>
-      <p:sp>
-        <p:nvSpPr>
-          <p:cNvPr id="16" name="Text 14"/>
-          <p:cNvSpPr txBox="1"/>
-          <p:nvPr/>
-        </p:nvSpPr>
-        <p:spPr>
-          <a:xfrm>
-            <a:off x="777240" y="2926080"/>
-            <a:ext cx="1645920" cy="256032"/>
-          </a:xfrm>
-          <a:prstGeom prst="rect">
-            <a:avLst/>
-          </a:prstGeom>
-          <a:noFill/>
-          <a:ln/>
-        </p:spPr>
-        <p:txBody>
-          <a:bodyPr wrap="square" lIns="0" tIns="0" rIns="0" bIns="0" rtlCol="0" anchor="ctr"/>
-          <a:lstStyle/>
-          <a:p>
-            <a:pPr indent="0" marL="0">
-              <a:buNone/>
-            </a:pPr>
-            <a:r>
-              <a:rPr lang="en-US" sz="1050" dirty="0">
+              <a:t>Progress per building</a:t>
+            </a:r>
+            <a:endParaRPr lang="en-US" sz="1250" dirty="0"/>
+          </a:p>
+          <a:p>
+            <a:pPr marL="177800" indent="-177800">
+              <a:spcAft>
+                <a:spcPts val="400"/>
+              </a:spcAft>
+              <a:buSzPct val="100000"/>
+              <a:buChar char="•"/>
+            </a:pPr>
+            <a:r>
+              <a:rPr lang="en-US" sz="1250" dirty="0">
                 <a:solidFill>
                   <a:srgbClr val="23272B"/>
                 </a:solidFill>
@@ -5968,38 +5587,20 @@
                 <a:ea typeface="Arial" pitchFamily="34" charset="-122"/>
                 <a:cs typeface="Arial" pitchFamily="34" charset="-120"/>
               </a:rPr>
-              <a:t>Sites</a:t>
-            </a:r>
-            <a:endParaRPr lang="en-US" sz="1050" dirty="0"/>
-          </a:p>
-        </p:txBody>
-      </p:sp>
-      <p:sp>
-        <p:nvSpPr>
-          <p:cNvPr id="17" name="Text 15"/>
-          <p:cNvSpPr txBox="1"/>
-          <p:nvPr/>
-        </p:nvSpPr>
-        <p:spPr>
-          <a:xfrm>
-            <a:off x="777240" y="3291840"/>
-            <a:ext cx="1645920" cy="256032"/>
-          </a:xfrm>
-          <a:prstGeom prst="rect">
-            <a:avLst/>
-          </a:prstGeom>
-          <a:noFill/>
-          <a:ln/>
-        </p:spPr>
-        <p:txBody>
-          <a:bodyPr wrap="square" lIns="0" tIns="0" rIns="0" bIns="0" rtlCol="0" anchor="ctr"/>
-          <a:lstStyle/>
-          <a:p>
-            <a:pPr indent="0" marL="0">
-              <a:buNone/>
-            </a:pPr>
-            <a:r>
-              <a:rPr lang="en-US" sz="1050" dirty="0">
+              <a:t>Planned vs actual schedule</a:t>
+            </a:r>
+            <a:endParaRPr lang="en-US" sz="1250" dirty="0"/>
+          </a:p>
+          <a:p>
+            <a:pPr marL="177800" indent="-177800">
+              <a:spcAft>
+                <a:spcPts val="400"/>
+              </a:spcAft>
+              <a:buSzPct val="100000"/>
+              <a:buChar char="•"/>
+            </a:pPr>
+            <a:r>
+              <a:rPr lang="en-US" sz="1250" dirty="0">
                 <a:solidFill>
                   <a:srgbClr val="23272B"/>
                 </a:solidFill>
@@ -6007,38 +5608,20 @@
                 <a:ea typeface="Arial" pitchFamily="34" charset="-122"/>
                 <a:cs typeface="Arial" pitchFamily="34" charset="-120"/>
               </a:rPr>
-              <a:t>Market prices</a:t>
-            </a:r>
-            <a:endParaRPr lang="en-US" sz="1050" dirty="0"/>
-          </a:p>
-        </p:txBody>
-      </p:sp>
-      <p:sp>
-        <p:nvSpPr>
-          <p:cNvPr id="18" name="Text 16"/>
-          <p:cNvSpPr txBox="1"/>
-          <p:nvPr/>
-        </p:nvSpPr>
-        <p:spPr>
-          <a:xfrm>
-            <a:off x="777240" y="3657600"/>
-            <a:ext cx="1645920" cy="256032"/>
-          </a:xfrm>
-          <a:prstGeom prst="rect">
-            <a:avLst/>
-          </a:prstGeom>
-          <a:noFill/>
-          <a:ln/>
-        </p:spPr>
-        <p:txBody>
-          <a:bodyPr wrap="square" lIns="0" tIns="0" rIns="0" bIns="0" rtlCol="0" anchor="ctr"/>
-          <a:lstStyle/>
-          <a:p>
-            <a:pPr indent="0" marL="0">
-              <a:buNone/>
-            </a:pPr>
-            <a:r>
-              <a:rPr lang="en-US" sz="1050" dirty="0">
+              <a:t>Daily site report summary</a:t>
+            </a:r>
+            <a:endParaRPr lang="en-US" sz="1250" dirty="0"/>
+          </a:p>
+          <a:p>
+            <a:pPr marL="177800" indent="-177800">
+              <a:spcAft>
+                <a:spcPts val="400"/>
+              </a:spcAft>
+              <a:buSzPct val="100000"/>
+              <a:buChar char="•"/>
+            </a:pPr>
+            <a:r>
+              <a:rPr lang="en-US" sz="1250" dirty="0">
                 <a:solidFill>
                   <a:srgbClr val="23272B"/>
                 </a:solidFill>
@@ -6046,256 +5629,22 @@
                 <a:ea typeface="Arial" pitchFamily="34" charset="-122"/>
                 <a:cs typeface="Arial" pitchFamily="34" charset="-120"/>
               </a:rPr>
-              <a:t>Purchasing</a:t>
-            </a:r>
-            <a:endParaRPr lang="en-US" sz="1050" dirty="0"/>
-          </a:p>
-        </p:txBody>
-      </p:sp>
-      <p:sp>
-        <p:nvSpPr>
-          <p:cNvPr id="19" name="Text 17"/>
-          <p:cNvSpPr txBox="1"/>
-          <p:nvPr/>
-        </p:nvSpPr>
-        <p:spPr>
-          <a:xfrm>
-            <a:off x="777240" y="4023360"/>
-            <a:ext cx="1645920" cy="256032"/>
-          </a:xfrm>
-          <a:prstGeom prst="rect">
-            <a:avLst/>
-          </a:prstGeom>
-          <a:noFill/>
-          <a:ln/>
-        </p:spPr>
-        <p:txBody>
-          <a:bodyPr wrap="square" lIns="0" tIns="0" rIns="0" bIns="0" rtlCol="0" anchor="ctr"/>
-          <a:lstStyle/>
-          <a:p>
-            <a:pPr indent="0" marL="0">
-              <a:buNone/>
-            </a:pPr>
-            <a:r>
-              <a:rPr lang="en-US" sz="1050" dirty="0">
-                <a:solidFill>
-                  <a:srgbClr val="23272B"/>
-                </a:solidFill>
-                <a:latin typeface="Arial" pitchFamily="34" charset="0"/>
-                <a:ea typeface="Arial" pitchFamily="34" charset="-122"/>
-                <a:cs typeface="Arial" pitchFamily="34" charset="-120"/>
-              </a:rPr>
-              <a:t>Stock</a:t>
-            </a:r>
-            <a:endParaRPr lang="en-US" sz="1050" dirty="0"/>
-          </a:p>
-        </p:txBody>
-      </p:sp>
-      <p:sp>
-        <p:nvSpPr>
-          <p:cNvPr id="20" name="Text 18"/>
-          <p:cNvSpPr txBox="1"/>
-          <p:nvPr/>
-        </p:nvSpPr>
-        <p:spPr>
-          <a:xfrm>
-            <a:off x="777240" y="4389120"/>
-            <a:ext cx="1645920" cy="256032"/>
-          </a:xfrm>
-          <a:prstGeom prst="rect">
-            <a:avLst/>
-          </a:prstGeom>
-          <a:noFill/>
-          <a:ln/>
-        </p:spPr>
-        <p:txBody>
-          <a:bodyPr wrap="square" lIns="0" tIns="0" rIns="0" bIns="0" rtlCol="0" anchor="ctr"/>
-          <a:lstStyle/>
-          <a:p>
-            <a:pPr indent="0" marL="0">
-              <a:buNone/>
-            </a:pPr>
-            <a:r>
-              <a:rPr lang="en-US" sz="1050" dirty="0">
-                <a:solidFill>
-                  <a:srgbClr val="23272B"/>
-                </a:solidFill>
-                <a:latin typeface="Arial" pitchFamily="34" charset="0"/>
-                <a:ea typeface="Arial" pitchFamily="34" charset="-122"/>
-                <a:cs typeface="Arial" pitchFamily="34" charset="-120"/>
-              </a:rPr>
-              <a:t>Finance</a:t>
-            </a:r>
-            <a:endParaRPr lang="en-US" sz="1050" dirty="0"/>
-          </a:p>
-        </p:txBody>
-      </p:sp>
-      <p:sp>
-        <p:nvSpPr>
-          <p:cNvPr id="21" name="Text 19"/>
-          <p:cNvSpPr txBox="1"/>
-          <p:nvPr/>
-        </p:nvSpPr>
-        <p:spPr>
-          <a:xfrm>
-            <a:off x="777240" y="4754880"/>
-            <a:ext cx="1645920" cy="256032"/>
-          </a:xfrm>
-          <a:prstGeom prst="rect">
-            <a:avLst/>
-          </a:prstGeom>
-          <a:noFill/>
-          <a:ln/>
-        </p:spPr>
-        <p:txBody>
-          <a:bodyPr wrap="square" lIns="0" tIns="0" rIns="0" bIns="0" rtlCol="0" anchor="ctr"/>
-          <a:lstStyle/>
-          <a:p>
-            <a:pPr indent="0" marL="0">
-              <a:buNone/>
-            </a:pPr>
-            <a:r>
-              <a:rPr lang="en-US" sz="1050" dirty="0">
-                <a:solidFill>
-                  <a:srgbClr val="23272B"/>
-                </a:solidFill>
-                <a:latin typeface="Arial" pitchFamily="34" charset="0"/>
-                <a:ea typeface="Arial" pitchFamily="34" charset="-122"/>
-                <a:cs typeface="Arial" pitchFamily="34" charset="-120"/>
-              </a:rPr>
-              <a:t>Client billing</a:t>
-            </a:r>
-            <a:endParaRPr lang="en-US" sz="1050" dirty="0"/>
-          </a:p>
-        </p:txBody>
-      </p:sp>
-      <p:sp>
-        <p:nvSpPr>
-          <p:cNvPr id="22" name="Text 20"/>
-          <p:cNvSpPr txBox="1"/>
-          <p:nvPr/>
-        </p:nvSpPr>
-        <p:spPr>
-          <a:xfrm>
-            <a:off x="777240" y="5120640"/>
-            <a:ext cx="1645920" cy="256032"/>
-          </a:xfrm>
-          <a:prstGeom prst="rect">
-            <a:avLst/>
-          </a:prstGeom>
-          <a:noFill/>
-          <a:ln/>
-        </p:spPr>
-        <p:txBody>
-          <a:bodyPr wrap="square" lIns="0" tIns="0" rIns="0" bIns="0" rtlCol="0" anchor="ctr"/>
-          <a:lstStyle/>
-          <a:p>
-            <a:pPr indent="0" marL="0">
-              <a:buNone/>
-            </a:pPr>
-            <a:r>
-              <a:rPr lang="en-US" sz="1050" dirty="0">
-                <a:solidFill>
-                  <a:srgbClr val="23272B"/>
-                </a:solidFill>
-                <a:latin typeface="Arial" pitchFamily="34" charset="0"/>
-                <a:ea typeface="Arial" pitchFamily="34" charset="-122"/>
-                <a:cs typeface="Arial" pitchFamily="34" charset="-120"/>
-              </a:rPr>
-              <a:t>HR &amp; workers</a:t>
-            </a:r>
-            <a:endParaRPr lang="en-US" sz="1050" dirty="0"/>
-          </a:p>
-        </p:txBody>
-      </p:sp>
-      <p:sp>
-        <p:nvSpPr>
-          <p:cNvPr id="23" name="Text 21"/>
-          <p:cNvSpPr txBox="1"/>
-          <p:nvPr/>
-        </p:nvSpPr>
-        <p:spPr>
-          <a:xfrm>
-            <a:off x="777240" y="5486400"/>
-            <a:ext cx="1645920" cy="256032"/>
-          </a:xfrm>
-          <a:prstGeom prst="rect">
-            <a:avLst/>
-          </a:prstGeom>
-          <a:noFill/>
-          <a:ln/>
-        </p:spPr>
-        <p:txBody>
-          <a:bodyPr wrap="square" lIns="0" tIns="0" rIns="0" bIns="0" rtlCol="0" anchor="ctr"/>
-          <a:lstStyle/>
-          <a:p>
-            <a:pPr indent="0" marL="0">
-              <a:buNone/>
-            </a:pPr>
-            <a:r>
-              <a:rPr lang="en-US" sz="1050" dirty="0">
-                <a:solidFill>
-                  <a:srgbClr val="23272B"/>
-                </a:solidFill>
-                <a:latin typeface="Arial" pitchFamily="34" charset="0"/>
-                <a:ea typeface="Arial" pitchFamily="34" charset="-122"/>
-                <a:cs typeface="Arial" pitchFamily="34" charset="-120"/>
-              </a:rPr>
-              <a:t>Machines</a:t>
-            </a:r>
-            <a:endParaRPr lang="en-US" sz="1050" dirty="0"/>
-          </a:p>
-        </p:txBody>
-      </p:sp>
-      <p:sp>
-        <p:nvSpPr>
-          <p:cNvPr id="24" name="Text 22"/>
-          <p:cNvSpPr txBox="1"/>
-          <p:nvPr/>
-        </p:nvSpPr>
-        <p:spPr>
-          <a:xfrm>
-            <a:off x="777240" y="5852160"/>
-            <a:ext cx="1645920" cy="256032"/>
-          </a:xfrm>
-          <a:prstGeom prst="rect">
-            <a:avLst/>
-          </a:prstGeom>
-          <a:noFill/>
-          <a:ln/>
-        </p:spPr>
-        <p:txBody>
-          <a:bodyPr wrap="square" lIns="0" tIns="0" rIns="0" bIns="0" rtlCol="0" anchor="ctr"/>
-          <a:lstStyle/>
-          <a:p>
-            <a:pPr indent="0" marL="0">
-              <a:buNone/>
-            </a:pPr>
-            <a:r>
-              <a:rPr lang="en-US" sz="1050" dirty="0">
-                <a:solidFill>
-                  <a:srgbClr val="23272B"/>
-                </a:solidFill>
-                <a:latin typeface="Arial" pitchFamily="34" charset="0"/>
-                <a:ea typeface="Arial" pitchFamily="34" charset="-122"/>
-                <a:cs typeface="Arial" pitchFamily="34" charset="-120"/>
-              </a:rPr>
-              <a:t>Reports</a:t>
-            </a:r>
-            <a:endParaRPr lang="en-US" sz="1050" dirty="0"/>
-          </a:p>
-        </p:txBody>
-      </p:sp>
-      <p:sp>
-        <p:nvSpPr>
-          <p:cNvPr id="25" name="Shape 23"/>
+              <a:t>Client billing status</a:t>
+            </a:r>
+            <a:endParaRPr lang="en-US" sz="1250" dirty="0"/>
+          </a:p>
+        </p:txBody>
+      </p:sp>
+      <p:sp>
+        <p:nvSpPr>
+          <p:cNvPr id="14" name="Shape 11"/>
           <p:cNvSpPr/>
           <p:nvPr/>
         </p:nvSpPr>
         <p:spPr>
           <a:xfrm>
-            <a:off x="2697480" y="2240280"/>
-            <a:ext cx="2057400" cy="868680"/>
+            <a:off x="4297680" y="1783080"/>
+            <a:ext cx="3566160" cy="2057400"/>
           </a:xfrm>
           <a:prstGeom prst="rect">
             <a:avLst/>
@@ -6313,14 +5662,63 @@
       </p:sp>
       <p:sp>
         <p:nvSpPr>
-          <p:cNvPr id="26" name="Text 24"/>
-          <p:cNvSpPr txBox="1"/>
-          <p:nvPr/>
-        </p:nvSpPr>
-        <p:spPr>
-          <a:xfrm>
-            <a:off x="2834640" y="2304288"/>
-            <a:ext cx="1828800" cy="411480"/>
+          <p:cNvPr id="15" name="Shape 12"/>
+          <p:cNvSpPr/>
+          <p:nvPr/>
+        </p:nvSpPr>
+        <p:spPr>
+          <a:xfrm>
+            <a:off x="4297680" y="1783080"/>
+            <a:ext cx="566928" cy="566928"/>
+          </a:xfrm>
+          <a:prstGeom prst="rect">
+            <a:avLst/>
+          </a:prstGeom>
+          <a:solidFill>
+            <a:srgbClr val="34495E"/>
+          </a:solidFill>
+          <a:ln w="12700">
+            <a:solidFill>
+              <a:srgbClr val="34495E"/>
+            </a:solidFill>
+            <a:prstDash val="solid"/>
+          </a:ln>
+        </p:spPr>
+      </p:sp>
+      <p:pic>
+        <p:nvPicPr>
+          <p:cNvPr id="16" name="Image 1" descr="preencoded.png">    </p:cNvPr>
+          <p:cNvPicPr>
+            <a:picLocks noChangeAspect="1"/>
+          </p:cNvPicPr>
+          <p:nvPr/>
+        </p:nvPicPr>
+        <p:blipFill>
+          <a:blip r:embed="rId2"/>
+          <a:stretch>
+            <a:fillRect/>
+          </a:stretch>
+        </p:blipFill>
+        <p:spPr>
+          <a:xfrm>
+            <a:off x="4422404" y="1907804"/>
+            <a:ext cx="317480" cy="317480"/>
+          </a:xfrm>
+          <a:prstGeom prst="rect">
+            <a:avLst/>
+          </a:prstGeom>
+        </p:spPr>
+      </p:pic>
+      <p:sp>
+        <p:nvSpPr>
+          <p:cNvPr id="17" name="Text 13"/>
+          <p:cNvSpPr txBox="1"/>
+          <p:nvPr/>
+        </p:nvSpPr>
+        <p:spPr>
+          <a:xfrm>
+            <a:off x="5029200" y="1783080"/>
+            <a:ext cx="2743200" cy="566928"/>
           </a:xfrm>
           <a:prstGeom prst="rect">
             <a:avLst/>
@@ -6336,7 +5734,7 @@
               <a:buNone/>
             </a:pPr>
             <a:r>
-              <a:rPr lang="en-US" sz="2000" b="1" dirty="0">
+              <a:rPr lang="en-US" sz="1500" b="1" dirty="0">
                 <a:solidFill>
                   <a:srgbClr val="1E2226"/>
                 </a:solidFill>
@@ -6344,61 +5742,128 @@
                 <a:ea typeface="Arial" pitchFamily="34" charset="-122"/>
                 <a:cs typeface="Arial" pitchFamily="34" charset="-120"/>
               </a:rPr>
-              <a:t>4</a:t>
-            </a:r>
-            <a:endParaRPr lang="en-US" sz="2000" dirty="0"/>
-          </a:p>
-        </p:txBody>
-      </p:sp>
-      <p:sp>
-        <p:nvSpPr>
-          <p:cNvPr id="27" name="Text 25"/>
-          <p:cNvSpPr txBox="1"/>
-          <p:nvPr/>
-        </p:nvSpPr>
-        <p:spPr>
-          <a:xfrm>
-            <a:off x="2834640" y="2743200"/>
-            <a:ext cx="1828800" cy="274320"/>
-          </a:xfrm>
-          <a:prstGeom prst="rect">
-            <a:avLst/>
-          </a:prstGeom>
-          <a:noFill/>
-          <a:ln/>
-        </p:spPr>
-        <p:txBody>
-          <a:bodyPr wrap="square" lIns="0" tIns="0" rIns="0" bIns="0" rtlCol="0" anchor="ctr"/>
-          <a:lstStyle/>
-          <a:p>
-            <a:pPr indent="0" marL="0">
-              <a:buNone/>
-            </a:pPr>
-            <a:r>
-              <a:rPr lang="en-US" sz="1050" dirty="0">
-                <a:solidFill>
-                  <a:srgbClr val="5F6670"/>
-                </a:solidFill>
-                <a:latin typeface="Arial" pitchFamily="34" charset="0"/>
-                <a:ea typeface="Arial" pitchFamily="34" charset="-122"/>
-                <a:cs typeface="Arial" pitchFamily="34" charset="-120"/>
-              </a:rPr>
-              <a:t>Active buildings</a:t>
-            </a:r>
-            <a:endParaRPr lang="en-US" sz="1050" dirty="0"/>
-          </a:p>
-        </p:txBody>
-      </p:sp>
-      <p:sp>
-        <p:nvSpPr>
-          <p:cNvPr id="28" name="Shape 26"/>
+              <a:t>Sales &amp; purchasing</a:t>
+            </a:r>
+            <a:endParaRPr lang="en-US" sz="1500" dirty="0"/>
+          </a:p>
+        </p:txBody>
+      </p:sp>
+      <p:sp>
+        <p:nvSpPr>
+          <p:cNvPr id="18" name="Text 14"/>
+          <p:cNvSpPr txBox="1"/>
+          <p:nvPr/>
+        </p:nvSpPr>
+        <p:spPr>
+          <a:xfrm>
+            <a:off x="4526280" y="2514600"/>
+            <a:ext cx="3154680" cy="1234440"/>
+          </a:xfrm>
+          <a:prstGeom prst="rect">
+            <a:avLst/>
+          </a:prstGeom>
+          <a:noFill/>
+          <a:ln/>
+        </p:spPr>
+        <p:txBody>
+          <a:bodyPr wrap="square" lIns="0" tIns="0" rIns="0" bIns="0" rtlCol="0" anchor="t"/>
+          <a:lstStyle/>
+          <a:p>
+            <a:pPr marL="177800" indent="-177800">
+              <a:spcAft>
+                <a:spcPts val="400"/>
+              </a:spcAft>
+              <a:buSzPct val="100000"/>
+              <a:buChar char="•"/>
+            </a:pPr>
+            <a:r>
+              <a:rPr lang="en-US" sz="1250" dirty="0">
+                <a:solidFill>
+                  <a:srgbClr val="23272B"/>
+                </a:solidFill>
+                <a:latin typeface="Arial" pitchFamily="34" charset="0"/>
+                <a:ea typeface="Arial" pitchFamily="34" charset="-122"/>
+                <a:cs typeface="Arial" pitchFamily="34" charset="-120"/>
+              </a:rPr>
+              <a:t>Market price history per material</a:t>
+            </a:r>
+            <a:endParaRPr lang="en-US" sz="1250" dirty="0"/>
+          </a:p>
+          <a:p>
+            <a:pPr marL="177800" indent="-177800">
+              <a:spcAft>
+                <a:spcPts val="400"/>
+              </a:spcAft>
+              <a:buSzPct val="100000"/>
+              <a:buChar char="•"/>
+            </a:pPr>
+            <a:r>
+              <a:rPr lang="en-US" sz="1250" dirty="0">
+                <a:solidFill>
+                  <a:srgbClr val="23272B"/>
+                </a:solidFill>
+                <a:latin typeface="Arial" pitchFamily="34" charset="0"/>
+                <a:ea typeface="Arial" pitchFamily="34" charset="-122"/>
+                <a:cs typeface="Arial" pitchFamily="34" charset="-120"/>
+              </a:rPr>
+              <a:t>Purchases per supplier</a:t>
+            </a:r>
+            <a:endParaRPr lang="en-US" sz="1250" dirty="0"/>
+          </a:p>
+          <a:p>
+            <a:pPr marL="177800" indent="-177800">
+              <a:spcAft>
+                <a:spcPts val="400"/>
+              </a:spcAft>
+              <a:buSzPct val="100000"/>
+              <a:buChar char="•"/>
+            </a:pPr>
+            <a:r>
+              <a:rPr lang="en-US" sz="1250" dirty="0">
+                <a:solidFill>
+                  <a:srgbClr val="23272B"/>
+                </a:solidFill>
+                <a:latin typeface="Arial" pitchFamily="34" charset="0"/>
+                <a:ea typeface="Arial" pitchFamily="34" charset="-122"/>
+                <a:cs typeface="Arial" pitchFamily="34" charset="-120"/>
+              </a:rPr>
+              <a:t>Sales and profit per customer</a:t>
+            </a:r>
+            <a:endParaRPr lang="en-US" sz="1250" dirty="0"/>
+          </a:p>
+          <a:p>
+            <a:pPr marL="177800" indent="-177800">
+              <a:spcAft>
+                <a:spcPts val="400"/>
+              </a:spcAft>
+              <a:buSzPct val="100000"/>
+              <a:buChar char="•"/>
+            </a:pPr>
+            <a:r>
+              <a:rPr lang="en-US" sz="1250" dirty="0">
+                <a:solidFill>
+                  <a:srgbClr val="23272B"/>
+                </a:solidFill>
+                <a:latin typeface="Arial" pitchFamily="34" charset="0"/>
+                <a:ea typeface="Arial" pitchFamily="34" charset="-122"/>
+                <a:cs typeface="Arial" pitchFamily="34" charset="-120"/>
+              </a:rPr>
+              <a:t>Customer and supplier balances</a:t>
+            </a:r>
+            <a:endParaRPr lang="en-US" sz="1250" dirty="0"/>
+          </a:p>
+        </p:txBody>
+      </p:sp>
+      <p:sp>
+        <p:nvSpPr>
+          <p:cNvPr id="19" name="Shape 15"/>
           <p:cNvSpPr/>
           <p:nvPr/>
         </p:nvSpPr>
         <p:spPr>
           <a:xfrm>
-            <a:off x="4892040" y="2240280"/>
-            <a:ext cx="2057400" cy="868680"/>
+            <a:off x="8046720" y="1783080"/>
+            <a:ext cx="3566160" cy="2057400"/>
           </a:xfrm>
           <a:prstGeom prst="rect">
             <a:avLst/>
@@ -6416,117 +5881,63 @@
       </p:sp>
       <p:sp>
         <p:nvSpPr>
-          <p:cNvPr id="29" name="Text 27"/>
-          <p:cNvSpPr txBox="1"/>
-          <p:nvPr/>
-        </p:nvSpPr>
-        <p:spPr>
-          <a:xfrm>
-            <a:off x="5029200" y="2304288"/>
-            <a:ext cx="1828800" cy="411480"/>
-          </a:xfrm>
-          <a:prstGeom prst="rect">
-            <a:avLst/>
-          </a:prstGeom>
-          <a:noFill/>
-          <a:ln/>
-        </p:spPr>
-        <p:txBody>
-          <a:bodyPr wrap="square" lIns="0" tIns="0" rIns="0" bIns="0" rtlCol="0" anchor="ctr"/>
-          <a:lstStyle/>
-          <a:p>
-            <a:pPr indent="0" marL="0">
-              <a:buNone/>
-            </a:pPr>
-            <a:r>
-              <a:rPr lang="en-US" sz="2000" b="1" dirty="0">
-                <a:solidFill>
-                  <a:srgbClr val="1E2226"/>
-                </a:solidFill>
-                <a:latin typeface="Arial" pitchFamily="34" charset="0"/>
-                <a:ea typeface="Arial" pitchFamily="34" charset="-122"/>
-                <a:cs typeface="Arial" pitchFamily="34" charset="-120"/>
-              </a:rPr>
-              <a:t>ETB 3.2M</a:t>
-            </a:r>
-            <a:endParaRPr lang="en-US" sz="2000" dirty="0"/>
-          </a:p>
-        </p:txBody>
-      </p:sp>
-      <p:sp>
-        <p:nvSpPr>
-          <p:cNvPr id="30" name="Text 28"/>
-          <p:cNvSpPr txBox="1"/>
-          <p:nvPr/>
-        </p:nvSpPr>
-        <p:spPr>
-          <a:xfrm>
-            <a:off x="5029200" y="2743200"/>
-            <a:ext cx="1828800" cy="274320"/>
-          </a:xfrm>
-          <a:prstGeom prst="rect">
-            <a:avLst/>
-          </a:prstGeom>
-          <a:noFill/>
-          <a:ln/>
-        </p:spPr>
-        <p:txBody>
-          <a:bodyPr wrap="square" lIns="0" tIns="0" rIns="0" bIns="0" rtlCol="0" anchor="ctr"/>
-          <a:lstStyle/>
-          <a:p>
-            <a:pPr indent="0" marL="0">
-              <a:buNone/>
-            </a:pPr>
-            <a:r>
-              <a:rPr lang="en-US" sz="1050" dirty="0">
-                <a:solidFill>
-                  <a:srgbClr val="5F6670"/>
-                </a:solidFill>
-                <a:latin typeface="Arial" pitchFamily="34" charset="0"/>
-                <a:ea typeface="Arial" pitchFamily="34" charset="-122"/>
-                <a:cs typeface="Arial" pitchFamily="34" charset="-120"/>
-              </a:rPr>
-              <a:t>Cash &amp; bank</a:t>
-            </a:r>
-            <a:endParaRPr lang="en-US" sz="1050" dirty="0"/>
-          </a:p>
-        </p:txBody>
-      </p:sp>
-      <p:sp>
-        <p:nvSpPr>
-          <p:cNvPr id="31" name="Shape 29"/>
+          <p:cNvPr id="20" name="Shape 16"/>
           <p:cNvSpPr/>
           <p:nvPr/>
         </p:nvSpPr>
         <p:spPr>
           <a:xfrm>
-            <a:off x="7086600" y="2240280"/>
-            <a:ext cx="2057400" cy="868680"/>
+            <a:off x="8046720" y="1783080"/>
+            <a:ext cx="566928" cy="566928"/>
           </a:xfrm>
           <a:prstGeom prst="rect">
             <a:avLst/>
           </a:prstGeom>
           <a:solidFill>
-            <a:srgbClr val="FDEBDD"/>
+            <a:srgbClr val="E8590C"/>
           </a:solidFill>
           <a:ln w="12700">
             <a:solidFill>
-              <a:srgbClr val="FDEBDD"/>
+              <a:srgbClr val="E8590C"/>
             </a:solidFill>
             <a:prstDash val="solid"/>
           </a:ln>
         </p:spPr>
       </p:sp>
-      <p:sp>
-        <p:nvSpPr>
-          <p:cNvPr id="32" name="Text 30"/>
-          <p:cNvSpPr txBox="1"/>
-          <p:nvPr/>
-        </p:nvSpPr>
-        <p:spPr>
-          <a:xfrm>
-            <a:off x="7223760" y="2304288"/>
-            <a:ext cx="1828800" cy="411480"/>
+      <p:pic>
+        <p:nvPicPr>
+          <p:cNvPr id="21" name="Image 2" descr="preencoded.png">    </p:cNvPr>
+          <p:cNvPicPr>
+            <a:picLocks noChangeAspect="1"/>
+          </p:cNvPicPr>
+          <p:nvPr/>
+        </p:nvPicPr>
+        <p:blipFill>
+          <a:blip r:embed="rId3"/>
+          <a:stretch>
+            <a:fillRect/>
+          </a:stretch>
+        </p:blipFill>
+        <p:spPr>
+          <a:xfrm>
+            <a:off x="8171444" y="1907804"/>
+            <a:ext cx="317480" cy="317480"/>
+          </a:xfrm>
+          <a:prstGeom prst="rect">
+            <a:avLst/>
+          </a:prstGeom>
+        </p:spPr>
+      </p:pic>
+      <p:sp>
+        <p:nvSpPr>
+          <p:cNvPr id="22" name="Text 17"/>
+          <p:cNvSpPr txBox="1"/>
+          <p:nvPr/>
+        </p:nvSpPr>
+        <p:spPr>
+          <a:xfrm>
+            <a:off x="8778240" y="1783080"/>
+            <a:ext cx="2743200" cy="566928"/>
           </a:xfrm>
           <a:prstGeom prst="rect">
             <a:avLst/>
@@ -6542,69 +5953,136 @@
               <a:buNone/>
             </a:pPr>
             <a:r>
-              <a:rPr lang="en-US" sz="2000" b="1" dirty="0">
-                <a:solidFill>
-                  <a:srgbClr val="E8590C"/>
-                </a:solidFill>
-                <a:latin typeface="Arial" pitchFamily="34" charset="0"/>
-                <a:ea typeface="Arial" pitchFamily="34" charset="-122"/>
-                <a:cs typeface="Arial" pitchFamily="34" charset="-120"/>
-              </a:rPr>
-              <a:t>ETB 1.8M</a:t>
-            </a:r>
-            <a:endParaRPr lang="en-US" sz="2000" dirty="0"/>
-          </a:p>
-        </p:txBody>
-      </p:sp>
-      <p:sp>
-        <p:nvSpPr>
-          <p:cNvPr id="33" name="Text 31"/>
-          <p:cNvSpPr txBox="1"/>
-          <p:nvPr/>
-        </p:nvSpPr>
-        <p:spPr>
-          <a:xfrm>
-            <a:off x="7223760" y="2743200"/>
-            <a:ext cx="1828800" cy="274320"/>
-          </a:xfrm>
-          <a:prstGeom prst="rect">
-            <a:avLst/>
-          </a:prstGeom>
-          <a:noFill/>
-          <a:ln/>
-        </p:spPr>
-        <p:txBody>
-          <a:bodyPr wrap="square" lIns="0" tIns="0" rIns="0" bIns="0" rtlCol="0" anchor="ctr"/>
-          <a:lstStyle/>
-          <a:p>
-            <a:pPr indent="0" marL="0">
-              <a:buNone/>
-            </a:pPr>
-            <a:r>
-              <a:rPr lang="en-US" sz="1050" dirty="0">
-                <a:solidFill>
-                  <a:srgbClr val="5F6670"/>
-                </a:solidFill>
-                <a:latin typeface="Arial" pitchFamily="34" charset="0"/>
-                <a:ea typeface="Arial" pitchFamily="34" charset="-122"/>
-                <a:cs typeface="Arial" pitchFamily="34" charset="-120"/>
-              </a:rPr>
-              <a:t>Unpaid client bills</a:t>
-            </a:r>
-            <a:endParaRPr lang="en-US" sz="1050" dirty="0"/>
-          </a:p>
-        </p:txBody>
-      </p:sp>
-      <p:sp>
-        <p:nvSpPr>
-          <p:cNvPr id="34" name="Shape 32"/>
+              <a:rPr lang="en-US" sz="1500" b="1" dirty="0">
+                <a:solidFill>
+                  <a:srgbClr val="1E2226"/>
+                </a:solidFill>
+                <a:latin typeface="Arial" pitchFamily="34" charset="0"/>
+                <a:ea typeface="Arial" pitchFamily="34" charset="-122"/>
+                <a:cs typeface="Arial" pitchFamily="34" charset="-120"/>
+              </a:rPr>
+              <a:t>Stock &amp; machines</a:t>
+            </a:r>
+            <a:endParaRPr lang="en-US" sz="1500" dirty="0"/>
+          </a:p>
+        </p:txBody>
+      </p:sp>
+      <p:sp>
+        <p:nvSpPr>
+          <p:cNvPr id="23" name="Text 18"/>
+          <p:cNvSpPr txBox="1"/>
+          <p:nvPr/>
+        </p:nvSpPr>
+        <p:spPr>
+          <a:xfrm>
+            <a:off x="8275320" y="2514600"/>
+            <a:ext cx="3154680" cy="1234440"/>
+          </a:xfrm>
+          <a:prstGeom prst="rect">
+            <a:avLst/>
+          </a:prstGeom>
+          <a:noFill/>
+          <a:ln/>
+        </p:spPr>
+        <p:txBody>
+          <a:bodyPr wrap="square" lIns="0" tIns="0" rIns="0" bIns="0" rtlCol="0" anchor="t"/>
+          <a:lstStyle/>
+          <a:p>
+            <a:pPr marL="177800" indent="-177800">
+              <a:spcAft>
+                <a:spcPts val="400"/>
+              </a:spcAft>
+              <a:buSzPct val="100000"/>
+              <a:buChar char="•"/>
+            </a:pPr>
+            <a:r>
+              <a:rPr lang="en-US" sz="1250" dirty="0">
+                <a:solidFill>
+                  <a:srgbClr val="23272B"/>
+                </a:solidFill>
+                <a:latin typeface="Arial" pitchFamily="34" charset="0"/>
+                <a:ea typeface="Arial" pitchFamily="34" charset="-122"/>
+                <a:cs typeface="Arial" pitchFamily="34" charset="-120"/>
+              </a:rPr>
+              <a:t>Stock balance per store</a:t>
+            </a:r>
+            <a:endParaRPr lang="en-US" sz="1250" dirty="0"/>
+          </a:p>
+          <a:p>
+            <a:pPr marL="177800" indent="-177800">
+              <a:spcAft>
+                <a:spcPts val="400"/>
+              </a:spcAft>
+              <a:buSzPct val="100000"/>
+              <a:buChar char="•"/>
+            </a:pPr>
+            <a:r>
+              <a:rPr lang="en-US" sz="1250" dirty="0">
+                <a:solidFill>
+                  <a:srgbClr val="23272B"/>
+                </a:solidFill>
+                <a:latin typeface="Arial" pitchFamily="34" charset="0"/>
+                <a:ea typeface="Arial" pitchFamily="34" charset="-122"/>
+                <a:cs typeface="Arial" pitchFamily="34" charset="-120"/>
+              </a:rPr>
+              <a:t>Material used vs planned</a:t>
+            </a:r>
+            <a:endParaRPr lang="en-US" sz="1250" dirty="0"/>
+          </a:p>
+          <a:p>
+            <a:pPr marL="177800" indent="-177800">
+              <a:spcAft>
+                <a:spcPts val="400"/>
+              </a:spcAft>
+              <a:buSzPct val="100000"/>
+              <a:buChar char="•"/>
+            </a:pPr>
+            <a:r>
+              <a:rPr lang="en-US" sz="1250" dirty="0">
+                <a:solidFill>
+                  <a:srgbClr val="23272B"/>
+                </a:solidFill>
+                <a:latin typeface="Arial" pitchFamily="34" charset="0"/>
+                <a:ea typeface="Arial" pitchFamily="34" charset="-122"/>
+                <a:cs typeface="Arial" pitchFamily="34" charset="-120"/>
+              </a:rPr>
+              <a:t>Transfers between stores</a:t>
+            </a:r>
+            <a:endParaRPr lang="en-US" sz="1250" dirty="0"/>
+          </a:p>
+          <a:p>
+            <a:pPr marL="177800" indent="-177800">
+              <a:spcAft>
+                <a:spcPts val="400"/>
+              </a:spcAft>
+              <a:buSzPct val="100000"/>
+              <a:buChar char="•"/>
+            </a:pPr>
+            <a:r>
+              <a:rPr lang="en-US" sz="1250" dirty="0">
+                <a:solidFill>
+                  <a:srgbClr val="23272B"/>
+                </a:solidFill>
+                <a:latin typeface="Arial" pitchFamily="34" charset="0"/>
+                <a:ea typeface="Arial" pitchFamily="34" charset="-122"/>
+                <a:cs typeface="Arial" pitchFamily="34" charset="-120"/>
+              </a:rPr>
+              <a:t>Machine fuel and repair cost</a:t>
+            </a:r>
+            <a:endParaRPr lang="en-US" sz="1250" dirty="0"/>
+          </a:p>
+        </p:txBody>
+      </p:sp>
+      <p:sp>
+        <p:nvSpPr>
+          <p:cNvPr id="24" name="Shape 19"/>
           <p:cNvSpPr/>
           <p:nvPr/>
         </p:nvSpPr>
         <p:spPr>
           <a:xfrm>
-            <a:off x="9281160" y="2240280"/>
-            <a:ext cx="2057400" cy="868680"/>
+            <a:off x="548640" y="4023360"/>
+            <a:ext cx="3566160" cy="2057400"/>
           </a:xfrm>
           <a:prstGeom prst="rect">
             <a:avLst/>
@@ -6622,679 +6100,63 @@
       </p:sp>
       <p:sp>
         <p:nvSpPr>
-          <p:cNvPr id="35" name="Text 33"/>
-          <p:cNvSpPr txBox="1"/>
-          <p:nvPr/>
-        </p:nvSpPr>
-        <p:spPr>
-          <a:xfrm>
-            <a:off x="9418320" y="2304288"/>
-            <a:ext cx="1828800" cy="411480"/>
-          </a:xfrm>
-          <a:prstGeom prst="rect">
-            <a:avLst/>
-          </a:prstGeom>
-          <a:noFill/>
-          <a:ln/>
-        </p:spPr>
-        <p:txBody>
-          <a:bodyPr wrap="square" lIns="0" tIns="0" rIns="0" bIns="0" rtlCol="0" anchor="ctr"/>
-          <a:lstStyle/>
-          <a:p>
-            <a:pPr indent="0" marL="0">
-              <a:buNone/>
-            </a:pPr>
-            <a:r>
-              <a:rPr lang="en-US" sz="2000" b="1" dirty="0">
-                <a:solidFill>
-                  <a:srgbClr val="1E2226"/>
-                </a:solidFill>
-                <a:latin typeface="Arial" pitchFamily="34" charset="0"/>
-                <a:ea typeface="Arial" pitchFamily="34" charset="-122"/>
-                <a:cs typeface="Arial" pitchFamily="34" charset="-120"/>
-              </a:rPr>
-              <a:t>186</a:t>
-            </a:r>
-            <a:endParaRPr lang="en-US" sz="2000" dirty="0"/>
-          </a:p>
-        </p:txBody>
-      </p:sp>
-      <p:sp>
-        <p:nvSpPr>
-          <p:cNvPr id="36" name="Text 34"/>
-          <p:cNvSpPr txBox="1"/>
-          <p:nvPr/>
-        </p:nvSpPr>
-        <p:spPr>
-          <a:xfrm>
-            <a:off x="9418320" y="2743200"/>
-            <a:ext cx="1828800" cy="274320"/>
-          </a:xfrm>
-          <a:prstGeom prst="rect">
-            <a:avLst/>
-          </a:prstGeom>
-          <a:noFill/>
-          <a:ln/>
-        </p:spPr>
-        <p:txBody>
-          <a:bodyPr wrap="square" lIns="0" tIns="0" rIns="0" bIns="0" rtlCol="0" anchor="ctr"/>
-          <a:lstStyle/>
-          <a:p>
-            <a:pPr indent="0" marL="0">
-              <a:buNone/>
-            </a:pPr>
-            <a:r>
-              <a:rPr lang="en-US" sz="1050" dirty="0">
-                <a:solidFill>
-                  <a:srgbClr val="5F6670"/>
-                </a:solidFill>
-                <a:latin typeface="Arial" pitchFamily="34" charset="0"/>
-                <a:ea typeface="Arial" pitchFamily="34" charset="-122"/>
-                <a:cs typeface="Arial" pitchFamily="34" charset="-120"/>
-              </a:rPr>
-              <a:t>Workers on site today</a:t>
-            </a:r>
-            <a:endParaRPr lang="en-US" sz="1050" dirty="0"/>
-          </a:p>
-        </p:txBody>
-      </p:sp>
-      <p:graphicFrame>
-        <p:nvGraphicFramePr>
-          <p:cNvPr id="37" name="Chart 0" descr=""/>
-          <p:cNvGraphicFramePr/>
-          <p:nvPr/>
-        </p:nvGraphicFramePr>
-        <p:xfrm>
-          <a:off x="2697480" y="3291840"/>
-          <a:ext cx="3840480" cy="2834640"/>
-        </p:xfrm>
-        <a:graphic xmlns:a="http://schemas.openxmlformats.org/drawingml/2006/main">
-          <a:graphicData uri="http://schemas.openxmlformats.org/drawingml/2006/chart">
-            <c:chart xmlns:c="http://schemas.openxmlformats.org/drawingml/2006/chart" r:id="rId1"/>
-          </a:graphicData>
-        </a:graphic>
-      </p:graphicFrame>
-      <p:sp>
-        <p:nvSpPr>
-          <p:cNvPr id="38" name="Text 35"/>
-          <p:cNvSpPr txBox="1"/>
-          <p:nvPr/>
-        </p:nvSpPr>
-        <p:spPr>
-          <a:xfrm>
-            <a:off x="6720840" y="3310128"/>
-            <a:ext cx="2194560" cy="274320"/>
-          </a:xfrm>
-          <a:prstGeom prst="rect">
-            <a:avLst/>
-          </a:prstGeom>
-          <a:noFill/>
-          <a:ln/>
-        </p:spPr>
-        <p:txBody>
-          <a:bodyPr wrap="square" lIns="0" tIns="0" rIns="0" bIns="0" rtlCol="0" anchor="ctr"/>
-          <a:lstStyle/>
-          <a:p>
-            <a:pPr indent="0" marL="0">
-              <a:buNone/>
-            </a:pPr>
-            <a:r>
-              <a:rPr lang="en-US" sz="1100" b="1" dirty="0">
-                <a:solidFill>
-                  <a:srgbClr val="1E2226"/>
-                </a:solidFill>
-                <a:latin typeface="Arial" pitchFamily="34" charset="0"/>
-                <a:ea typeface="Arial" pitchFamily="34" charset="-122"/>
-                <a:cs typeface="Arial" pitchFamily="34" charset="-120"/>
-              </a:rPr>
-              <a:t>Today's prices (sample)</a:t>
-            </a:r>
-            <a:endParaRPr lang="en-US" sz="1100" dirty="0"/>
-          </a:p>
-        </p:txBody>
-      </p:sp>
-      <p:sp>
-        <p:nvSpPr>
-          <p:cNvPr id="39" name="Text 36"/>
-          <p:cNvSpPr txBox="1"/>
-          <p:nvPr/>
-        </p:nvSpPr>
-        <p:spPr>
-          <a:xfrm>
-            <a:off x="6720840" y="3657600"/>
-            <a:ext cx="1234440" cy="274320"/>
-          </a:xfrm>
-          <a:prstGeom prst="rect">
-            <a:avLst/>
-          </a:prstGeom>
-          <a:noFill/>
-          <a:ln/>
-        </p:spPr>
-        <p:txBody>
-          <a:bodyPr wrap="square" lIns="0" tIns="0" rIns="0" bIns="0" rtlCol="0" anchor="ctr"/>
-          <a:lstStyle/>
-          <a:p>
-            <a:pPr indent="0" marL="0">
-              <a:buNone/>
-            </a:pPr>
-            <a:r>
-              <a:rPr lang="en-US" sz="1000" dirty="0">
-                <a:solidFill>
-                  <a:srgbClr val="23272B"/>
-                </a:solidFill>
-                <a:latin typeface="Arial" pitchFamily="34" charset="0"/>
-                <a:ea typeface="Arial" pitchFamily="34" charset="-122"/>
-                <a:cs typeface="Arial" pitchFamily="34" charset="-120"/>
-              </a:rPr>
-              <a:t>Cement 50 kg</a:t>
-            </a:r>
-            <a:endParaRPr lang="en-US" sz="1000" dirty="0"/>
-          </a:p>
-        </p:txBody>
-      </p:sp>
-      <p:sp>
-        <p:nvSpPr>
-          <p:cNvPr id="40" name="Text 37"/>
-          <p:cNvSpPr txBox="1"/>
-          <p:nvPr/>
-        </p:nvSpPr>
-        <p:spPr>
-          <a:xfrm>
-            <a:off x="7955280" y="3657600"/>
-            <a:ext cx="914400" cy="274320"/>
-          </a:xfrm>
-          <a:prstGeom prst="rect">
-            <a:avLst/>
-          </a:prstGeom>
-          <a:noFill/>
-          <a:ln/>
-        </p:spPr>
-        <p:txBody>
-          <a:bodyPr wrap="square" lIns="0" tIns="0" rIns="0" bIns="0" rtlCol="0" anchor="ctr"/>
-          <a:lstStyle/>
-          <a:p>
-            <a:pPr indent="0" marL="0">
-              <a:buNone/>
-            </a:pPr>
-            <a:r>
-              <a:rPr lang="en-US" sz="1000" dirty="0">
-                <a:solidFill>
-                  <a:srgbClr val="5F6670"/>
-                </a:solidFill>
-                <a:latin typeface="Arial" pitchFamily="34" charset="0"/>
-                <a:ea typeface="Arial" pitchFamily="34" charset="-122"/>
-                <a:cs typeface="Arial" pitchFamily="34" charset="-120"/>
-              </a:rPr>
-              <a:t>Merkato</a:t>
-            </a:r>
-            <a:endParaRPr lang="en-US" sz="1000" dirty="0"/>
-          </a:p>
-        </p:txBody>
-      </p:sp>
-      <p:sp>
-        <p:nvSpPr>
-          <p:cNvPr id="41" name="Text 38"/>
-          <p:cNvSpPr txBox="1"/>
-          <p:nvPr/>
-        </p:nvSpPr>
-        <p:spPr>
-          <a:xfrm>
-            <a:off x="8823960" y="3657600"/>
-            <a:ext cx="228600" cy="274320"/>
-          </a:xfrm>
-          <a:prstGeom prst="rect">
-            <a:avLst/>
-          </a:prstGeom>
-          <a:noFill/>
-          <a:ln/>
-        </p:spPr>
-        <p:txBody>
-          <a:bodyPr wrap="square" lIns="0" tIns="0" rIns="0" bIns="0" rtlCol="0" anchor="ctr"/>
-          <a:lstStyle/>
-          <a:p>
-            <a:pPr indent="0" marL="0">
-              <a:buNone/>
-            </a:pPr>
-            <a:r>
-              <a:rPr lang="en-US" sz="1000" b="1" dirty="0">
-                <a:solidFill>
-                  <a:srgbClr val="E8590C"/>
-                </a:solidFill>
-                <a:latin typeface="Arial" pitchFamily="34" charset="0"/>
-                <a:ea typeface="Arial" pitchFamily="34" charset="-122"/>
-                <a:cs typeface="Arial" pitchFamily="34" charset="-120"/>
-              </a:rPr>
-              <a:t>▲</a:t>
-            </a:r>
-            <a:endParaRPr lang="en-US" sz="1000" dirty="0"/>
-          </a:p>
-        </p:txBody>
-      </p:sp>
-      <p:sp>
-        <p:nvSpPr>
-          <p:cNvPr id="42" name="Text 39"/>
-          <p:cNvSpPr txBox="1"/>
-          <p:nvPr/>
-        </p:nvSpPr>
-        <p:spPr>
-          <a:xfrm>
-            <a:off x="6720840" y="4005072"/>
-            <a:ext cx="1234440" cy="274320"/>
-          </a:xfrm>
-          <a:prstGeom prst="rect">
-            <a:avLst/>
-          </a:prstGeom>
-          <a:noFill/>
-          <a:ln/>
-        </p:spPr>
-        <p:txBody>
-          <a:bodyPr wrap="square" lIns="0" tIns="0" rIns="0" bIns="0" rtlCol="0" anchor="ctr"/>
-          <a:lstStyle/>
-          <a:p>
-            <a:pPr indent="0" marL="0">
-              <a:buNone/>
-            </a:pPr>
-            <a:r>
-              <a:rPr lang="en-US" sz="1000" dirty="0">
-                <a:solidFill>
-                  <a:srgbClr val="23272B"/>
-                </a:solidFill>
-                <a:latin typeface="Arial" pitchFamily="34" charset="0"/>
-                <a:ea typeface="Arial" pitchFamily="34" charset="-122"/>
-                <a:cs typeface="Arial" pitchFamily="34" charset="-120"/>
-              </a:rPr>
-              <a:t>Rebar Ø12</a:t>
-            </a:r>
-            <a:endParaRPr lang="en-US" sz="1000" dirty="0"/>
-          </a:p>
-        </p:txBody>
-      </p:sp>
-      <p:sp>
-        <p:nvSpPr>
-          <p:cNvPr id="43" name="Text 40"/>
-          <p:cNvSpPr txBox="1"/>
-          <p:nvPr/>
-        </p:nvSpPr>
-        <p:spPr>
-          <a:xfrm>
-            <a:off x="7955280" y="4005072"/>
-            <a:ext cx="914400" cy="274320"/>
-          </a:xfrm>
-          <a:prstGeom prst="rect">
-            <a:avLst/>
-          </a:prstGeom>
-          <a:noFill/>
-          <a:ln/>
-        </p:spPr>
-        <p:txBody>
-          <a:bodyPr wrap="square" lIns="0" tIns="0" rIns="0" bIns="0" rtlCol="0" anchor="ctr"/>
-          <a:lstStyle/>
-          <a:p>
-            <a:pPr indent="0" marL="0">
-              <a:buNone/>
-            </a:pPr>
-            <a:r>
-              <a:rPr lang="en-US" sz="1000" dirty="0">
-                <a:solidFill>
-                  <a:srgbClr val="5F6670"/>
-                </a:solidFill>
-                <a:latin typeface="Arial" pitchFamily="34" charset="0"/>
-                <a:ea typeface="Arial" pitchFamily="34" charset="-122"/>
-                <a:cs typeface="Arial" pitchFamily="34" charset="-120"/>
-              </a:rPr>
-              <a:t>Kality</a:t>
-            </a:r>
-            <a:endParaRPr lang="en-US" sz="1000" dirty="0"/>
-          </a:p>
-        </p:txBody>
-      </p:sp>
-      <p:sp>
-        <p:nvSpPr>
-          <p:cNvPr id="44" name="Text 41"/>
-          <p:cNvSpPr txBox="1"/>
-          <p:nvPr/>
-        </p:nvSpPr>
-        <p:spPr>
-          <a:xfrm>
-            <a:off x="8823960" y="4005072"/>
-            <a:ext cx="228600" cy="274320"/>
-          </a:xfrm>
-          <a:prstGeom prst="rect">
-            <a:avLst/>
-          </a:prstGeom>
-          <a:noFill/>
-          <a:ln/>
-        </p:spPr>
-        <p:txBody>
-          <a:bodyPr wrap="square" lIns="0" tIns="0" rIns="0" bIns="0" rtlCol="0" anchor="ctr"/>
-          <a:lstStyle/>
-          <a:p>
-            <a:pPr indent="0" marL="0">
-              <a:buNone/>
-            </a:pPr>
-            <a:r>
-              <a:rPr lang="en-US" sz="1000" b="1" dirty="0">
-                <a:solidFill>
-                  <a:srgbClr val="34495E"/>
-                </a:solidFill>
-                <a:latin typeface="Arial" pitchFamily="34" charset="0"/>
-                <a:ea typeface="Arial" pitchFamily="34" charset="-122"/>
-                <a:cs typeface="Arial" pitchFamily="34" charset="-120"/>
-              </a:rPr>
-              <a:t>▼</a:t>
-            </a:r>
-            <a:endParaRPr lang="en-US" sz="1000" dirty="0"/>
-          </a:p>
-        </p:txBody>
-      </p:sp>
-      <p:sp>
-        <p:nvSpPr>
-          <p:cNvPr id="45" name="Text 42"/>
-          <p:cNvSpPr txBox="1"/>
-          <p:nvPr/>
-        </p:nvSpPr>
-        <p:spPr>
-          <a:xfrm>
-            <a:off x="6720840" y="4352544"/>
-            <a:ext cx="1234440" cy="274320"/>
-          </a:xfrm>
-          <a:prstGeom prst="rect">
-            <a:avLst/>
-          </a:prstGeom>
-          <a:noFill/>
-          <a:ln/>
-        </p:spPr>
-        <p:txBody>
-          <a:bodyPr wrap="square" lIns="0" tIns="0" rIns="0" bIns="0" rtlCol="0" anchor="ctr"/>
-          <a:lstStyle/>
-          <a:p>
-            <a:pPr indent="0" marL="0">
-              <a:buNone/>
-            </a:pPr>
-            <a:r>
-              <a:rPr lang="en-US" sz="1000" dirty="0">
-                <a:solidFill>
-                  <a:srgbClr val="23272B"/>
-                </a:solidFill>
-                <a:latin typeface="Arial" pitchFamily="34" charset="0"/>
-                <a:ea typeface="Arial" pitchFamily="34" charset="-122"/>
-                <a:cs typeface="Arial" pitchFamily="34" charset="-120"/>
-              </a:rPr>
-              <a:t>Hollow block</a:t>
-            </a:r>
-            <a:endParaRPr lang="en-US" sz="1000" dirty="0"/>
-          </a:p>
-        </p:txBody>
-      </p:sp>
-      <p:sp>
-        <p:nvSpPr>
-          <p:cNvPr id="46" name="Text 43"/>
-          <p:cNvSpPr txBox="1"/>
-          <p:nvPr/>
-        </p:nvSpPr>
-        <p:spPr>
-          <a:xfrm>
-            <a:off x="7955280" y="4352544"/>
-            <a:ext cx="914400" cy="274320"/>
-          </a:xfrm>
-          <a:prstGeom prst="rect">
-            <a:avLst/>
-          </a:prstGeom>
-          <a:noFill/>
-          <a:ln/>
-        </p:spPr>
-        <p:txBody>
-          <a:bodyPr wrap="square" lIns="0" tIns="0" rIns="0" bIns="0" rtlCol="0" anchor="ctr"/>
-          <a:lstStyle/>
-          <a:p>
-            <a:pPr indent="0" marL="0">
-              <a:buNone/>
-            </a:pPr>
-            <a:r>
-              <a:rPr lang="en-US" sz="1000" dirty="0">
-                <a:solidFill>
-                  <a:srgbClr val="5F6670"/>
-                </a:solidFill>
-                <a:latin typeface="Arial" pitchFamily="34" charset="0"/>
-                <a:ea typeface="Arial" pitchFamily="34" charset="-122"/>
-                <a:cs typeface="Arial" pitchFamily="34" charset="-120"/>
-              </a:rPr>
-              <a:t>Merkato</a:t>
-            </a:r>
-            <a:endParaRPr lang="en-US" sz="1000" dirty="0"/>
-          </a:p>
-        </p:txBody>
-      </p:sp>
-      <p:sp>
-        <p:nvSpPr>
-          <p:cNvPr id="47" name="Text 44"/>
-          <p:cNvSpPr txBox="1"/>
-          <p:nvPr/>
-        </p:nvSpPr>
-        <p:spPr>
-          <a:xfrm>
-            <a:off x="8823960" y="4352544"/>
-            <a:ext cx="228600" cy="274320"/>
-          </a:xfrm>
-          <a:prstGeom prst="rect">
-            <a:avLst/>
-          </a:prstGeom>
-          <a:noFill/>
-          <a:ln/>
-        </p:spPr>
-        <p:txBody>
-          <a:bodyPr wrap="square" lIns="0" tIns="0" rIns="0" bIns="0" rtlCol="0" anchor="ctr"/>
-          <a:lstStyle/>
-          <a:p>
-            <a:pPr indent="0" marL="0">
-              <a:buNone/>
-            </a:pPr>
-            <a:r>
-              <a:rPr lang="en-US" sz="1000" b="1" dirty="0">
-                <a:solidFill>
-                  <a:srgbClr val="34495E"/>
-                </a:solidFill>
-                <a:latin typeface="Arial" pitchFamily="34" charset="0"/>
-                <a:ea typeface="Arial" pitchFamily="34" charset="-122"/>
-                <a:cs typeface="Arial" pitchFamily="34" charset="-120"/>
-              </a:rPr>
-              <a:t>–</a:t>
-            </a:r>
-            <a:endParaRPr lang="en-US" sz="1000" dirty="0"/>
-          </a:p>
-        </p:txBody>
-      </p:sp>
-      <p:sp>
-        <p:nvSpPr>
-          <p:cNvPr id="48" name="Text 45"/>
-          <p:cNvSpPr txBox="1"/>
-          <p:nvPr/>
-        </p:nvSpPr>
-        <p:spPr>
-          <a:xfrm>
-            <a:off x="6720840" y="4700016"/>
-            <a:ext cx="1234440" cy="274320"/>
-          </a:xfrm>
-          <a:prstGeom prst="rect">
-            <a:avLst/>
-          </a:prstGeom>
-          <a:noFill/>
-          <a:ln/>
-        </p:spPr>
-        <p:txBody>
-          <a:bodyPr wrap="square" lIns="0" tIns="0" rIns="0" bIns="0" rtlCol="0" anchor="ctr"/>
-          <a:lstStyle/>
-          <a:p>
-            <a:pPr indent="0" marL="0">
-              <a:buNone/>
-            </a:pPr>
-            <a:r>
-              <a:rPr lang="en-US" sz="1000" dirty="0">
-                <a:solidFill>
-                  <a:srgbClr val="23272B"/>
-                </a:solidFill>
-                <a:latin typeface="Arial" pitchFamily="34" charset="0"/>
-                <a:ea typeface="Arial" pitchFamily="34" charset="-122"/>
-                <a:cs typeface="Arial" pitchFamily="34" charset="-120"/>
-              </a:rPr>
-              <a:t>Sand m³</a:t>
-            </a:r>
-            <a:endParaRPr lang="en-US" sz="1000" dirty="0"/>
-          </a:p>
-        </p:txBody>
-      </p:sp>
-      <p:sp>
-        <p:nvSpPr>
-          <p:cNvPr id="49" name="Text 46"/>
-          <p:cNvSpPr txBox="1"/>
-          <p:nvPr/>
-        </p:nvSpPr>
-        <p:spPr>
-          <a:xfrm>
-            <a:off x="7955280" y="4700016"/>
-            <a:ext cx="914400" cy="274320"/>
-          </a:xfrm>
-          <a:prstGeom prst="rect">
-            <a:avLst/>
-          </a:prstGeom>
-          <a:noFill/>
-          <a:ln/>
-        </p:spPr>
-        <p:txBody>
-          <a:bodyPr wrap="square" lIns="0" tIns="0" rIns="0" bIns="0" rtlCol="0" anchor="ctr"/>
-          <a:lstStyle/>
-          <a:p>
-            <a:pPr indent="0" marL="0">
-              <a:buNone/>
-            </a:pPr>
-            <a:r>
-              <a:rPr lang="en-US" sz="1000" dirty="0">
-                <a:solidFill>
-                  <a:srgbClr val="5F6670"/>
-                </a:solidFill>
-                <a:latin typeface="Arial" pitchFamily="34" charset="0"/>
-                <a:ea typeface="Arial" pitchFamily="34" charset="-122"/>
-                <a:cs typeface="Arial" pitchFamily="34" charset="-120"/>
-              </a:rPr>
-              <a:t>Site supplier</a:t>
-            </a:r>
-            <a:endParaRPr lang="en-US" sz="1000" dirty="0"/>
-          </a:p>
-        </p:txBody>
-      </p:sp>
-      <p:sp>
-        <p:nvSpPr>
-          <p:cNvPr id="50" name="Text 47"/>
-          <p:cNvSpPr txBox="1"/>
-          <p:nvPr/>
-        </p:nvSpPr>
-        <p:spPr>
-          <a:xfrm>
-            <a:off x="8823960" y="4700016"/>
-            <a:ext cx="228600" cy="274320"/>
-          </a:xfrm>
-          <a:prstGeom prst="rect">
-            <a:avLst/>
-          </a:prstGeom>
-          <a:noFill/>
-          <a:ln/>
-        </p:spPr>
-        <p:txBody>
-          <a:bodyPr wrap="square" lIns="0" tIns="0" rIns="0" bIns="0" rtlCol="0" anchor="ctr"/>
-          <a:lstStyle/>
-          <a:p>
-            <a:pPr indent="0" marL="0">
-              <a:buNone/>
-            </a:pPr>
-            <a:r>
-              <a:rPr lang="en-US" sz="1000" b="1" dirty="0">
-                <a:solidFill>
-                  <a:srgbClr val="E8590C"/>
-                </a:solidFill>
-                <a:latin typeface="Arial" pitchFamily="34" charset="0"/>
-                <a:ea typeface="Arial" pitchFamily="34" charset="-122"/>
-                <a:cs typeface="Arial" pitchFamily="34" charset="-120"/>
-              </a:rPr>
-              <a:t>▲</a:t>
-            </a:r>
-            <a:endParaRPr lang="en-US" sz="1000" dirty="0"/>
-          </a:p>
-        </p:txBody>
-      </p:sp>
-      <p:sp>
-        <p:nvSpPr>
-          <p:cNvPr id="51" name="Text 48"/>
-          <p:cNvSpPr txBox="1"/>
-          <p:nvPr/>
-        </p:nvSpPr>
-        <p:spPr>
-          <a:xfrm>
-            <a:off x="9189720" y="3310128"/>
-            <a:ext cx="1828800" cy="274320"/>
-          </a:xfrm>
-          <a:prstGeom prst="rect">
-            <a:avLst/>
-          </a:prstGeom>
-          <a:noFill/>
-          <a:ln/>
-        </p:spPr>
-        <p:txBody>
-          <a:bodyPr wrap="square" lIns="0" tIns="0" rIns="0" bIns="0" rtlCol="0" anchor="ctr"/>
-          <a:lstStyle/>
-          <a:p>
-            <a:pPr indent="0" marL="0">
-              <a:buNone/>
-            </a:pPr>
-            <a:r>
-              <a:rPr lang="en-US" sz="1100" b="1" dirty="0">
-                <a:solidFill>
-                  <a:srgbClr val="1E2226"/>
-                </a:solidFill>
-                <a:latin typeface="Arial" pitchFamily="34" charset="0"/>
-                <a:ea typeface="Arial" pitchFamily="34" charset="-122"/>
-                <a:cs typeface="Arial" pitchFamily="34" charset="-120"/>
-              </a:rPr>
-              <a:t>Alerts</a:t>
-            </a:r>
-            <a:endParaRPr lang="en-US" sz="1100" dirty="0"/>
-          </a:p>
-        </p:txBody>
-      </p:sp>
-      <p:sp>
-        <p:nvSpPr>
-          <p:cNvPr id="52" name="Shape 49"/>
+          <p:cNvPr id="25" name="Shape 20"/>
           <p:cNvSpPr/>
           <p:nvPr/>
         </p:nvSpPr>
         <p:spPr>
           <a:xfrm>
-            <a:off x="9189720" y="3657600"/>
-            <a:ext cx="2240280" cy="402336"/>
+            <a:off x="548640" y="4023360"/>
+            <a:ext cx="566928" cy="566928"/>
           </a:xfrm>
           <a:prstGeom prst="rect">
             <a:avLst/>
           </a:prstGeom>
           <a:solidFill>
-            <a:srgbClr val="FDEBDD"/>
+            <a:srgbClr val="34495E"/>
           </a:solidFill>
           <a:ln w="12700">
             <a:solidFill>
-              <a:srgbClr val="FDEBDD"/>
+              <a:srgbClr val="34495E"/>
             </a:solidFill>
             <a:prstDash val="solid"/>
           </a:ln>
         </p:spPr>
       </p:sp>
-      <p:sp>
-        <p:nvSpPr>
-          <p:cNvPr id="53" name="Text 50"/>
-          <p:cNvSpPr txBox="1"/>
-          <p:nvPr/>
-        </p:nvSpPr>
-        <p:spPr>
-          <a:xfrm>
-            <a:off x="9281160" y="3657600"/>
-            <a:ext cx="2103120" cy="402336"/>
+      <p:pic>
+        <p:nvPicPr>
+          <p:cNvPr id="26" name="Image 3" descr="preencoded.png">    </p:cNvPr>
+          <p:cNvPicPr>
+            <a:picLocks noChangeAspect="1"/>
+          </p:cNvPicPr>
+          <p:nvPr/>
+        </p:nvPicPr>
+        <p:blipFill>
+          <a:blip r:embed="rId4"/>
+          <a:stretch>
+            <a:fillRect/>
+          </a:stretch>
+        </p:blipFill>
+        <p:spPr>
+          <a:xfrm>
+            <a:off x="673364" y="4148084"/>
+            <a:ext cx="317480" cy="317480"/>
+          </a:xfrm>
+          <a:prstGeom prst="rect">
+            <a:avLst/>
+          </a:prstGeom>
+        </p:spPr>
+      </p:pic>
+      <p:sp>
+        <p:nvSpPr>
+          <p:cNvPr id="27" name="Text 21"/>
+          <p:cNvSpPr txBox="1"/>
+          <p:nvPr/>
+        </p:nvSpPr>
+        <p:spPr>
+          <a:xfrm>
+            <a:off x="1280160" y="4023360"/>
+            <a:ext cx="2743200" cy="566928"/>
           </a:xfrm>
           <a:prstGeom prst="rect">
             <a:avLst/>
@@ -7310,7 +6172,50 @@
               <a:buNone/>
             </a:pPr>
             <a:r>
-              <a:rPr lang="en-US" sz="950" dirty="0">
+              <a:rPr lang="en-US" sz="1500" b="1" dirty="0">
+                <a:solidFill>
+                  <a:srgbClr val="1E2226"/>
+                </a:solidFill>
+                <a:latin typeface="Arial" pitchFamily="34" charset="0"/>
+                <a:ea typeface="Arial" pitchFamily="34" charset="-122"/>
+                <a:cs typeface="Arial" pitchFamily="34" charset="-120"/>
+              </a:rPr>
+              <a:t>Finance</a:t>
+            </a:r>
+            <a:endParaRPr lang="en-US" sz="1500" dirty="0"/>
+          </a:p>
+        </p:txBody>
+      </p:sp>
+      <p:sp>
+        <p:nvSpPr>
+          <p:cNvPr id="28" name="Text 22"/>
+          <p:cNvSpPr txBox="1"/>
+          <p:nvPr/>
+        </p:nvSpPr>
+        <p:spPr>
+          <a:xfrm>
+            <a:off x="777240" y="4754880"/>
+            <a:ext cx="3154680" cy="1234440"/>
+          </a:xfrm>
+          <a:prstGeom prst="rect">
+            <a:avLst/>
+          </a:prstGeom>
+          <a:noFill/>
+          <a:ln/>
+        </p:spPr>
+        <p:txBody>
+          <a:bodyPr wrap="square" lIns="0" tIns="0" rIns="0" bIns="0" rtlCol="0" anchor="t"/>
+          <a:lstStyle/>
+          <a:p>
+            <a:pPr marL="177800" indent="-177800">
+              <a:spcAft>
+                <a:spcPts val="400"/>
+              </a:spcAft>
+              <a:buSzPct val="100000"/>
+              <a:buChar char="•"/>
+            </a:pPr>
+            <a:r>
+              <a:rPr lang="en-US" sz="1250" dirty="0">
                 <a:solidFill>
                   <a:srgbClr val="23272B"/>
                 </a:solidFill>
@@ -7318,86 +6223,85 @@
                 <a:ea typeface="Arial" pitchFamily="34" charset="-122"/>
                 <a:cs typeface="Arial" pitchFamily="34" charset="-120"/>
               </a:rPr>
-              <a:t>CMC G+5: 8% over budget</a:t>
-            </a:r>
-            <a:endParaRPr lang="en-US" sz="950" dirty="0"/>
-          </a:p>
-        </p:txBody>
-      </p:sp>
-      <p:sp>
-        <p:nvSpPr>
-          <p:cNvPr id="54" name="Shape 51"/>
+              <a:t>Income and expenses</a:t>
+            </a:r>
+            <a:endParaRPr lang="en-US" sz="1250" dirty="0"/>
+          </a:p>
+          <a:p>
+            <a:pPr marL="177800" indent="-177800">
+              <a:spcAft>
+                <a:spcPts val="400"/>
+              </a:spcAft>
+              <a:buSzPct val="100000"/>
+              <a:buChar char="•"/>
+            </a:pPr>
+            <a:r>
+              <a:rPr lang="en-US" sz="1250" dirty="0">
+                <a:solidFill>
+                  <a:srgbClr val="23272B"/>
+                </a:solidFill>
+                <a:latin typeface="Arial" pitchFamily="34" charset="0"/>
+                <a:ea typeface="Arial" pitchFamily="34" charset="-122"/>
+                <a:cs typeface="Arial" pitchFamily="34" charset="-120"/>
+              </a:rPr>
+              <a:t>Cost and profit per building</a:t>
+            </a:r>
+            <a:endParaRPr lang="en-US" sz="1250" dirty="0"/>
+          </a:p>
+          <a:p>
+            <a:pPr marL="177800" indent="-177800">
+              <a:spcAft>
+                <a:spcPts val="400"/>
+              </a:spcAft>
+              <a:buSzPct val="100000"/>
+              <a:buChar char="•"/>
+            </a:pPr>
+            <a:r>
+              <a:rPr lang="en-US" sz="1250" dirty="0">
+                <a:solidFill>
+                  <a:srgbClr val="23272B"/>
+                </a:solidFill>
+                <a:latin typeface="Arial" pitchFamily="34" charset="0"/>
+                <a:ea typeface="Arial" pitchFamily="34" charset="-122"/>
+                <a:cs typeface="Arial" pitchFamily="34" charset="-120"/>
+              </a:rPr>
+              <a:t>Bank and cash position</a:t>
+            </a:r>
+            <a:endParaRPr lang="en-US" sz="1250" dirty="0"/>
+          </a:p>
+          <a:p>
+            <a:pPr marL="177800" indent="-177800">
+              <a:spcAft>
+                <a:spcPts val="400"/>
+              </a:spcAft>
+              <a:buSzPct val="100000"/>
+              <a:buChar char="•"/>
+            </a:pPr>
+            <a:r>
+              <a:rPr lang="en-US" sz="1250" dirty="0">
+                <a:solidFill>
+                  <a:srgbClr val="23272B"/>
+                </a:solidFill>
+                <a:latin typeface="Arial" pitchFamily="34" charset="0"/>
+                <a:ea typeface="Arial" pitchFamily="34" charset="-122"/>
+                <a:cs typeface="Arial" pitchFamily="34" charset="-120"/>
+              </a:rPr>
+              <a:t>VAT and withholding reports</a:t>
+            </a:r>
+            <a:endParaRPr lang="en-US" sz="1250" dirty="0"/>
+          </a:p>
+        </p:txBody>
+      </p:sp>
+      <p:sp>
+        <p:nvSpPr>
+          <p:cNvPr id="29" name="Shape 23"/>
           <p:cNvSpPr/>
           <p:nvPr/>
         </p:nvSpPr>
         <p:spPr>
           <a:xfrm>
-            <a:off x="9189720" y="4133088"/>
-            <a:ext cx="2240280" cy="402336"/>
-          </a:xfrm>
-          <a:prstGeom prst="rect">
-            <a:avLst/>
-          </a:prstGeom>
-          <a:solidFill>
-            <a:srgbClr val="FDEBDD"/>
-          </a:solidFill>
-          <a:ln w="12700">
-            <a:solidFill>
-              <a:srgbClr val="FDEBDD"/>
-            </a:solidFill>
-            <a:prstDash val="solid"/>
-          </a:ln>
-        </p:spPr>
-      </p:sp>
-      <p:sp>
-        <p:nvSpPr>
-          <p:cNvPr id="55" name="Text 52"/>
-          <p:cNvSpPr txBox="1"/>
-          <p:nvPr/>
-        </p:nvSpPr>
-        <p:spPr>
-          <a:xfrm>
-            <a:off x="9281160" y="4133088"/>
-            <a:ext cx="2103120" cy="402336"/>
-          </a:xfrm>
-          <a:prstGeom prst="rect">
-            <a:avLst/>
-          </a:prstGeom>
-          <a:noFill/>
-          <a:ln/>
-        </p:spPr>
-        <p:txBody>
-          <a:bodyPr wrap="square" lIns="0" tIns="0" rIns="0" bIns="0" rtlCol="0" anchor="ctr"/>
-          <a:lstStyle/>
-          <a:p>
-            <a:pPr indent="0" marL="0">
-              <a:buNone/>
-            </a:pPr>
-            <a:r>
-              <a:rPr lang="en-US" sz="950" dirty="0">
-                <a:solidFill>
-                  <a:srgbClr val="23272B"/>
-                </a:solidFill>
-                <a:latin typeface="Arial" pitchFamily="34" charset="0"/>
-                <a:ea typeface="Arial" pitchFamily="34" charset="-122"/>
-                <a:cs typeface="Arial" pitchFamily="34" charset="-120"/>
-              </a:rPr>
-              <a:t>Client bill #3 overdue 21 days</a:t>
-            </a:r>
-            <a:endParaRPr lang="en-US" sz="950" dirty="0"/>
-          </a:p>
-        </p:txBody>
-      </p:sp>
-      <p:sp>
-        <p:nvSpPr>
-          <p:cNvPr id="56" name="Shape 53"/>
-          <p:cNvSpPr/>
-          <p:nvPr/>
-        </p:nvSpPr>
-        <p:spPr>
-          <a:xfrm>
-            <a:off x="9189720" y="4608576"/>
-            <a:ext cx="2240280" cy="402336"/>
+            <a:off x="4297680" y="4023360"/>
+            <a:ext cx="3566160" cy="2057400"/>
           </a:xfrm>
           <a:prstGeom prst="rect">
             <a:avLst/>
@@ -7415,14 +6319,63 @@
       </p:sp>
       <p:sp>
         <p:nvSpPr>
-          <p:cNvPr id="57" name="Text 54"/>
-          <p:cNvSpPr txBox="1"/>
-          <p:nvPr/>
-        </p:nvSpPr>
-        <p:spPr>
-          <a:xfrm>
-            <a:off x="9281160" y="4608576"/>
-            <a:ext cx="2103120" cy="402336"/>
+          <p:cNvPr id="30" name="Shape 24"/>
+          <p:cNvSpPr/>
+          <p:nvPr/>
+        </p:nvSpPr>
+        <p:spPr>
+          <a:xfrm>
+            <a:off x="4297680" y="4023360"/>
+            <a:ext cx="566928" cy="566928"/>
+          </a:xfrm>
+          <a:prstGeom prst="rect">
+            <a:avLst/>
+          </a:prstGeom>
+          <a:solidFill>
+            <a:srgbClr val="E8590C"/>
+          </a:solidFill>
+          <a:ln w="12700">
+            <a:solidFill>
+              <a:srgbClr val="E8590C"/>
+            </a:solidFill>
+            <a:prstDash val="solid"/>
+          </a:ln>
+        </p:spPr>
+      </p:sp>
+      <p:pic>
+        <p:nvPicPr>
+          <p:cNvPr id="31" name="Image 4" descr="preencoded.png">    </p:cNvPr>
+          <p:cNvPicPr>
+            <a:picLocks noChangeAspect="1"/>
+          </p:cNvPicPr>
+          <p:nvPr/>
+        </p:nvPicPr>
+        <p:blipFill>
+          <a:blip r:embed="rId5"/>
+          <a:stretch>
+            <a:fillRect/>
+          </a:stretch>
+        </p:blipFill>
+        <p:spPr>
+          <a:xfrm>
+            <a:off x="4422404" y="4148084"/>
+            <a:ext cx="317480" cy="317480"/>
+          </a:xfrm>
+          <a:prstGeom prst="rect">
+            <a:avLst/>
+          </a:prstGeom>
+        </p:spPr>
+      </p:pic>
+      <p:sp>
+        <p:nvSpPr>
+          <p:cNvPr id="32" name="Text 25"/>
+          <p:cNvSpPr txBox="1"/>
+          <p:nvPr/>
+        </p:nvSpPr>
+        <p:spPr>
+          <a:xfrm>
+            <a:off x="5029200" y="4023360"/>
+            <a:ext cx="2743200" cy="566928"/>
           </a:xfrm>
           <a:prstGeom prst="rect">
             <a:avLst/>
@@ -7438,7 +6391,50 @@
               <a:buNone/>
             </a:pPr>
             <a:r>
-              <a:rPr lang="en-US" sz="950" dirty="0">
+              <a:rPr lang="en-US" sz="1500" b="1" dirty="0">
+                <a:solidFill>
+                  <a:srgbClr val="1E2226"/>
+                </a:solidFill>
+                <a:latin typeface="Arial" pitchFamily="34" charset="0"/>
+                <a:ea typeface="Arial" pitchFamily="34" charset="-122"/>
+                <a:cs typeface="Arial" pitchFamily="34" charset="-120"/>
+              </a:rPr>
+              <a:t>HR &amp; workers</a:t>
+            </a:r>
+            <a:endParaRPr lang="en-US" sz="1500" dirty="0"/>
+          </a:p>
+        </p:txBody>
+      </p:sp>
+      <p:sp>
+        <p:nvSpPr>
+          <p:cNvPr id="33" name="Text 26"/>
+          <p:cNvSpPr txBox="1"/>
+          <p:nvPr/>
+        </p:nvSpPr>
+        <p:spPr>
+          <a:xfrm>
+            <a:off x="4526280" y="4754880"/>
+            <a:ext cx="3154680" cy="1234440"/>
+          </a:xfrm>
+          <a:prstGeom prst="rect">
+            <a:avLst/>
+          </a:prstGeom>
+          <a:noFill/>
+          <a:ln/>
+        </p:spPr>
+        <p:txBody>
+          <a:bodyPr wrap="square" lIns="0" tIns="0" rIns="0" bIns="0" rtlCol="0" anchor="t"/>
+          <a:lstStyle/>
+          <a:p>
+            <a:pPr marL="177800" indent="-177800">
+              <a:spcAft>
+                <a:spcPts val="400"/>
+              </a:spcAft>
+              <a:buSzPct val="100000"/>
+              <a:buChar char="•"/>
+            </a:pPr>
+            <a:r>
+              <a:rPr lang="en-US" sz="1250" dirty="0">
                 <a:solidFill>
                   <a:srgbClr val="23272B"/>
                 </a:solidFill>
@@ -7446,22 +6442,85 @@
                 <a:ea typeface="Arial" pitchFamily="34" charset="-122"/>
                 <a:cs typeface="Arial" pitchFamily="34" charset="-120"/>
               </a:rPr>
-              <a:t>Ayat site: cement below minimum</a:t>
-            </a:r>
-            <a:endParaRPr lang="en-US" sz="950" dirty="0"/>
-          </a:p>
-        </p:txBody>
-      </p:sp>
-      <p:sp>
-        <p:nvSpPr>
-          <p:cNvPr id="58" name="Shape 55"/>
+              <a:t>Attendance per site</a:t>
+            </a:r>
+            <a:endParaRPr lang="en-US" sz="1250" dirty="0"/>
+          </a:p>
+          <a:p>
+            <a:pPr marL="177800" indent="-177800">
+              <a:spcAft>
+                <a:spcPts val="400"/>
+              </a:spcAft>
+              <a:buSzPct val="100000"/>
+              <a:buChar char="•"/>
+            </a:pPr>
+            <a:r>
+              <a:rPr lang="en-US" sz="1250" dirty="0">
+                <a:solidFill>
+                  <a:srgbClr val="23272B"/>
+                </a:solidFill>
+                <a:latin typeface="Arial" pitchFamily="34" charset="0"/>
+                <a:ea typeface="Arial" pitchFamily="34" charset="-122"/>
+                <a:cs typeface="Arial" pitchFamily="34" charset="-120"/>
+              </a:rPr>
+              <a:t>Daily-worker pay sheets</a:t>
+            </a:r>
+            <a:endParaRPr lang="en-US" sz="1250" dirty="0"/>
+          </a:p>
+          <a:p>
+            <a:pPr marL="177800" indent="-177800">
+              <a:spcAft>
+                <a:spcPts val="400"/>
+              </a:spcAft>
+              <a:buSzPct val="100000"/>
+              <a:buChar char="•"/>
+            </a:pPr>
+            <a:r>
+              <a:rPr lang="en-US" sz="1250" dirty="0">
+                <a:solidFill>
+                  <a:srgbClr val="23272B"/>
+                </a:solidFill>
+                <a:latin typeface="Arial" pitchFamily="34" charset="0"/>
+                <a:ea typeface="Arial" pitchFamily="34" charset="-122"/>
+                <a:cs typeface="Arial" pitchFamily="34" charset="-120"/>
+              </a:rPr>
+              <a:t>Monthly payroll</a:t>
+            </a:r>
+            <a:endParaRPr lang="en-US" sz="1250" dirty="0"/>
+          </a:p>
+          <a:p>
+            <a:pPr marL="177800" indent="-177800">
+              <a:spcAft>
+                <a:spcPts val="400"/>
+              </a:spcAft>
+              <a:buSzPct val="100000"/>
+              <a:buChar char="•"/>
+            </a:pPr>
+            <a:r>
+              <a:rPr lang="en-US" sz="1250" dirty="0">
+                <a:solidFill>
+                  <a:srgbClr val="23272B"/>
+                </a:solidFill>
+                <a:latin typeface="Arial" pitchFamily="34" charset="0"/>
+                <a:ea typeface="Arial" pitchFamily="34" charset="-122"/>
+                <a:cs typeface="Arial" pitchFamily="34" charset="-120"/>
+              </a:rPr>
+              <a:t>Staff list and contracts</a:t>
+            </a:r>
+            <a:endParaRPr lang="en-US" sz="1250" dirty="0"/>
+          </a:p>
+        </p:txBody>
+      </p:sp>
+      <p:sp>
+        <p:nvSpPr>
+          <p:cNvPr id="34" name="Shape 27"/>
           <p:cNvSpPr/>
           <p:nvPr/>
         </p:nvSpPr>
         <p:spPr>
           <a:xfrm>
-            <a:off x="9189720" y="5084064"/>
-            <a:ext cx="2240280" cy="402336"/>
+            <a:off x="8046720" y="4023360"/>
+            <a:ext cx="3566160" cy="2057400"/>
           </a:xfrm>
           <a:prstGeom prst="rect">
             <a:avLst/>
@@ -7479,78 +6538,63 @@
       </p:sp>
       <p:sp>
         <p:nvSpPr>
-          <p:cNvPr id="59" name="Text 56"/>
-          <p:cNvSpPr txBox="1"/>
-          <p:nvPr/>
-        </p:nvSpPr>
-        <p:spPr>
-          <a:xfrm>
-            <a:off x="9281160" y="5084064"/>
-            <a:ext cx="2103120" cy="402336"/>
-          </a:xfrm>
-          <a:prstGeom prst="rect">
-            <a:avLst/>
-          </a:prstGeom>
-          <a:noFill/>
-          <a:ln/>
-        </p:spPr>
-        <p:txBody>
-          <a:bodyPr wrap="square" lIns="0" tIns="0" rIns="0" bIns="0" rtlCol="0" anchor="ctr"/>
-          <a:lstStyle/>
-          <a:p>
-            <a:pPr indent="0" marL="0">
-              <a:buNone/>
-            </a:pPr>
-            <a:r>
-              <a:rPr lang="en-US" sz="950" dirty="0">
-                <a:solidFill>
-                  <a:srgbClr val="23272B"/>
-                </a:solidFill>
-                <a:latin typeface="Arial" pitchFamily="34" charset="0"/>
-                <a:ea typeface="Arial" pitchFamily="34" charset="-122"/>
-                <a:cs typeface="Arial" pitchFamily="34" charset="-120"/>
-              </a:rPr>
-              <a:t>Guarantee expires in 14 days</a:t>
-            </a:r>
-            <a:endParaRPr lang="en-US" sz="950" dirty="0"/>
-          </a:p>
-        </p:txBody>
-      </p:sp>
-      <p:sp>
-        <p:nvSpPr>
-          <p:cNvPr id="60" name="Shape 57"/>
+          <p:cNvPr id="35" name="Shape 28"/>
           <p:cNvSpPr/>
           <p:nvPr/>
         </p:nvSpPr>
         <p:spPr>
           <a:xfrm>
-            <a:off x="9189720" y="5559552"/>
-            <a:ext cx="2240280" cy="402336"/>
+            <a:off x="8046720" y="4023360"/>
+            <a:ext cx="566928" cy="566928"/>
           </a:xfrm>
           <a:prstGeom prst="rect">
             <a:avLst/>
           </a:prstGeom>
           <a:solidFill>
-            <a:srgbClr val="F1F2F4"/>
+            <a:srgbClr val="34495E"/>
           </a:solidFill>
           <a:ln w="12700">
             <a:solidFill>
-              <a:srgbClr val="F1F2F4"/>
+              <a:srgbClr val="34495E"/>
             </a:solidFill>
             <a:prstDash val="solid"/>
           </a:ln>
         </p:spPr>
       </p:sp>
-      <p:sp>
-        <p:nvSpPr>
-          <p:cNvPr id="61" name="Text 58"/>
-          <p:cNvSpPr txBox="1"/>
-          <p:nvPr/>
-        </p:nvSpPr>
-        <p:spPr>
-          <a:xfrm>
-            <a:off x="9281160" y="5559552"/>
-            <a:ext cx="2103120" cy="402336"/>
+      <p:pic>
+        <p:nvPicPr>
+          <p:cNvPr id="36" name="Image 5" descr="preencoded.png">    </p:cNvPr>
+          <p:cNvPicPr>
+            <a:picLocks noChangeAspect="1"/>
+          </p:cNvPicPr>
+          <p:nvPr/>
+        </p:nvPicPr>
+        <p:blipFill>
+          <a:blip r:embed="rId6"/>
+          <a:stretch>
+            <a:fillRect/>
+          </a:stretch>
+        </p:blipFill>
+        <p:spPr>
+          <a:xfrm>
+            <a:off x="8171444" y="4148084"/>
+            <a:ext cx="317480" cy="317480"/>
+          </a:xfrm>
+          <a:prstGeom prst="rect">
+            <a:avLst/>
+          </a:prstGeom>
+        </p:spPr>
+      </p:pic>
+      <p:sp>
+        <p:nvSpPr>
+          <p:cNvPr id="37" name="Text 29"/>
+          <p:cNvSpPr txBox="1"/>
+          <p:nvPr/>
+        </p:nvSpPr>
+        <p:spPr>
+          <a:xfrm>
+            <a:off x="8778240" y="4023360"/>
+            <a:ext cx="2743200" cy="566928"/>
           </a:xfrm>
           <a:prstGeom prst="rect">
             <a:avLst/>
@@ -7566,7 +6610,50 @@
               <a:buNone/>
             </a:pPr>
             <a:r>
-              <a:rPr lang="en-US" sz="950" dirty="0">
+              <a:rPr lang="en-US" sz="1500" b="1" dirty="0">
+                <a:solidFill>
+                  <a:srgbClr val="1E2226"/>
+                </a:solidFill>
+                <a:latin typeface="Arial" pitchFamily="34" charset="0"/>
+                <a:ea typeface="Arial" pitchFamily="34" charset="-122"/>
+                <a:cs typeface="Arial" pitchFamily="34" charset="-120"/>
+              </a:rPr>
+              <a:t>Management</a:t>
+            </a:r>
+            <a:endParaRPr lang="en-US" sz="1500" dirty="0"/>
+          </a:p>
+        </p:txBody>
+      </p:sp>
+      <p:sp>
+        <p:nvSpPr>
+          <p:cNvPr id="38" name="Text 30"/>
+          <p:cNvSpPr txBox="1"/>
+          <p:nvPr/>
+        </p:nvSpPr>
+        <p:spPr>
+          <a:xfrm>
+            <a:off x="8275320" y="4754880"/>
+            <a:ext cx="3154680" cy="1234440"/>
+          </a:xfrm>
+          <a:prstGeom prst="rect">
+            <a:avLst/>
+          </a:prstGeom>
+          <a:noFill/>
+          <a:ln/>
+        </p:spPr>
+        <p:txBody>
+          <a:bodyPr wrap="square" lIns="0" tIns="0" rIns="0" bIns="0" rtlCol="0" anchor="t"/>
+          <a:lstStyle/>
+          <a:p>
+            <a:pPr marL="177800" indent="-177800">
+              <a:spcAft>
+                <a:spcPts val="400"/>
+              </a:spcAft>
+              <a:buSzPct val="100000"/>
+              <a:buChar char="•"/>
+            </a:pPr>
+            <a:r>
+              <a:rPr lang="en-US" sz="1250" dirty="0">
                 <a:solidFill>
                   <a:srgbClr val="23272B"/>
                 </a:solidFill>
@@ -7574,9 +6661,72 @@
                 <a:ea typeface="Arial" pitchFamily="34" charset="-122"/>
                 <a:cs typeface="Arial" pitchFamily="34" charset="-120"/>
               </a:rPr>
-              <a:t>5 payments missing receipts</a:t>
-            </a:r>
-            <a:endParaRPr lang="en-US" sz="950" dirty="0"/>
+              <a:t>All buildings at a glance</a:t>
+            </a:r>
+            <a:endParaRPr lang="en-US" sz="1250" dirty="0"/>
+          </a:p>
+          <a:p>
+            <a:pPr marL="177800" indent="-177800">
+              <a:spcAft>
+                <a:spcPts val="400"/>
+              </a:spcAft>
+              <a:buSzPct val="100000"/>
+              <a:buChar char="•"/>
+            </a:pPr>
+            <a:r>
+              <a:rPr lang="en-US" sz="1250" dirty="0">
+                <a:solidFill>
+                  <a:srgbClr val="23272B"/>
+                </a:solidFill>
+                <a:latin typeface="Arial" pitchFamily="34" charset="0"/>
+                <a:ea typeface="Arial" pitchFamily="34" charset="-122"/>
+                <a:cs typeface="Arial" pitchFamily="34" charset="-120"/>
+              </a:rPr>
+              <a:t>Budget vs actual summary</a:t>
+            </a:r>
+            <a:endParaRPr lang="en-US" sz="1250" dirty="0"/>
+          </a:p>
+          <a:p>
+            <a:pPr marL="177800" indent="-177800">
+              <a:spcAft>
+                <a:spcPts val="400"/>
+              </a:spcAft>
+              <a:buSzPct val="100000"/>
+              <a:buChar char="•"/>
+            </a:pPr>
+            <a:r>
+              <a:rPr lang="en-US" sz="1250" dirty="0">
+                <a:solidFill>
+                  <a:srgbClr val="23272B"/>
+                </a:solidFill>
+                <a:latin typeface="Arial" pitchFamily="34" charset="0"/>
+                <a:ea typeface="Arial" pitchFamily="34" charset="-122"/>
+                <a:cs typeface="Arial" pitchFamily="34" charset="-120"/>
+              </a:rPr>
+              <a:t>Overdue payments and alerts</a:t>
+            </a:r>
+            <a:endParaRPr lang="en-US" sz="1250" dirty="0"/>
+          </a:p>
+          <a:p>
+            <a:pPr marL="177800" indent="-177800">
+              <a:spcAft>
+                <a:spcPts val="400"/>
+              </a:spcAft>
+              <a:buSzPct val="100000"/>
+              <a:buChar char="•"/>
+            </a:pPr>
+            <a:r>
+              <a:rPr lang="en-US" sz="1250" dirty="0">
+                <a:solidFill>
+                  <a:srgbClr val="23272B"/>
+                </a:solidFill>
+                <a:latin typeface="Arial" pitchFamily="34" charset="0"/>
+                <a:ea typeface="Arial" pitchFamily="34" charset="-122"/>
+                <a:cs typeface="Arial" pitchFamily="34" charset="-120"/>
+              </a:rPr>
+              <a:t>Approvals waiting</a:t>
+            </a:r>
+            <a:endParaRPr lang="en-US" sz="1250" dirty="0"/>
           </a:p>
         </p:txBody>
       </p:sp>
@@ -11280,7 +10430,7 @@
                 <a:ea typeface="Arial" pitchFamily="34" charset="-122"/>
                 <a:cs typeface="Arial" pitchFamily="34" charset="-120"/>
               </a:rPr>
-              <a:t>Owner's dashboard updated</a:t>
+              <a:t>Management summary updated</a:t>
             </a:r>
             <a:endParaRPr lang="en-US" sz="1250" dirty="0"/>
           </a:p>
@@ -14023,7 +13173,7 @@
                 <a:ea typeface="Arial" pitchFamily="34" charset="-122"/>
                 <a:cs typeface="Arial" pitchFamily="34" charset="-120"/>
               </a:rPr>
-              <a:t>Sales &amp; prices, finance &amp; receipts, client billing, HR &amp; daily workers</a:t>
+              <a:t>Sales &amp; prices, finance, client billing, HR &amp; daily workers</a:t>
             </a:r>
             <a:endParaRPr lang="en-US" sz="950" dirty="0"/>
           </a:p>
@@ -15324,27 +14474,6 @@
                 <a:ea typeface="Arial" pitchFamily="34" charset="-122"/>
                 <a:cs typeface="Arial" pitchFamily="34" charset="-120"/>
               </a:rPr>
-              <a:t>3 months free support after go-live</a:t>
-            </a:r>
-            <a:endParaRPr lang="en-US" sz="1250" dirty="0"/>
-          </a:p>
-          <a:p>
-            <a:pPr marL="177800" indent="-177800">
-              <a:spcAft>
-                <a:spcPts val="500"/>
-              </a:spcAft>
-              <a:buSzPct val="100000"/>
-              <a:buChar char="•"/>
-            </a:pPr>
-            <a:r>
-              <a:rPr lang="en-US" sz="1250" dirty="0">
-                <a:solidFill>
-                  <a:srgbClr val="23272B"/>
-                </a:solidFill>
-                <a:latin typeface="Arial" pitchFamily="34" charset="0"/>
-                <a:ea typeface="Arial" pitchFamily="34" charset="-122"/>
-                <a:cs typeface="Arial" pitchFamily="34" charset="-120"/>
-              </a:rPr>
               <a:t>Your data belongs to you</a:t>
             </a:r>
             <a:endParaRPr lang="en-US" sz="1250" dirty="0"/>
@@ -15515,7 +14644,7 @@
                 <a:ea typeface="Arial" pitchFamily="34" charset="-122"/>
                 <a:cs typeface="Arial" pitchFamily="34" charset="-120"/>
               </a:rPr>
-              <a:t>Optional yearly support after the free period</a:t>
+              <a:t>Yearly support and maintenance (optional)</a:t>
             </a:r>
             <a:endParaRPr lang="en-US" sz="1150" dirty="0"/>
           </a:p>
@@ -15611,7 +14740,7 @@
                 <a:ea typeface="Arial" pitchFamily="34" charset="-122"/>
                 <a:cs typeface="Arial" pitchFamily="34" charset="-120"/>
               </a:rPr>
-              <a:t>12 · TO DISCUSS TOGETHER</a:t>
+              <a:t>12 · QUESTIONS</a:t>
             </a:r>
             <a:endParaRPr lang="en-US" sz="1100" dirty="0"/>
           </a:p>
@@ -17263,7 +16392,7 @@
                 <a:ea typeface="Arial" pitchFamily="34" charset="-122"/>
                 <a:cs typeface="Arial" pitchFamily="34" charset="-120"/>
               </a:rPr>
-              <a:t>01 · WHAT WE UNDERSTOOD</a:t>
+              <a:t>01 · UNDERSTANDING CONSTRUCTION</a:t>
             </a:r>
             <a:endParaRPr lang="en-US" sz="1100" dirty="0"/>
           </a:p>
@@ -17302,7 +16431,7 @@
                 <a:ea typeface="Arial" pitchFamily="34" charset="-122"/>
                 <a:cs typeface="Arial" pitchFamily="34" charset="-120"/>
               </a:rPr>
-              <a:t>Your business today</a:t>
+              <a:t>How a construction company works</a:t>
             </a:r>
             <a:endParaRPr lang="en-US" sz="2800" dirty="0"/>
           </a:p>
@@ -17341,7 +16470,7 @@
                 <a:ea typeface="Arial" pitchFamily="34" charset="-122"/>
                 <a:cs typeface="Arial" pitchFamily="34" charset="-120"/>
               </a:rPr>
-              <a:t>A building contractor delivering G+5 and larger buildings for its clients</a:t>
+              <a:t>What a building contractor manages every day</a:t>
             </a:r>
             <a:endParaRPr lang="en-US" sz="1400" dirty="0"/>
           </a:p>
@@ -17532,7 +16661,7 @@
                 <a:ea typeface="Arial" pitchFamily="34" charset="-122"/>
                 <a:cs typeface="Arial" pitchFamily="34" charset="-120"/>
               </a:rPr>
-              <a:t>Buildings for clients</a:t>
+              <a:t>Building projects for clients</a:t>
             </a:r>
             <a:endParaRPr lang="en-US" sz="1600" dirty="0"/>
           </a:p>
@@ -17571,7 +16700,7 @@
                 <a:ea typeface="Arial" pitchFamily="34" charset="-122"/>
                 <a:cs typeface="Arial" pitchFamily="34" charset="-120"/>
               </a:rPr>
-              <a:t>G+5 and above, several sites running at the same time</a:t>
+              <a:t>Several building sites running at the same time, each with its own budget and team</a:t>
             </a:r>
             <a:endParaRPr lang="en-US" sz="1250" dirty="0"/>
           </a:p>
@@ -17659,7 +16788,7 @@
                 <a:ea typeface="Arial" pitchFamily="34" charset="-122"/>
                 <a:cs typeface="Arial" pitchFamily="34" charset="-120"/>
               </a:rPr>
-              <a:t>Buys and sells materials</a:t>
+              <a:t>Buying and selling materials</a:t>
             </a:r>
             <a:endParaRPr lang="en-US" sz="1600" dirty="0"/>
           </a:p>
@@ -17698,7 +16827,7 @@
                 <a:ea typeface="Arial" pitchFamily="34" charset="-122"/>
                 <a:cs typeface="Arial" pitchFamily="34" charset="-120"/>
               </a:rPr>
-              <a:t>Tracks current prices in Merkato and other markets, buys for sites and sells to customers</a:t>
+              <a:t>Current prices in Merkato and other markets decide where to buy; materials are also sold to customers</a:t>
             </a:r>
             <a:endParaRPr lang="en-US" sz="1250" dirty="0"/>
           </a:p>
@@ -17786,7 +16915,7 @@
                 <a:ea typeface="Arial" pitchFamily="34" charset="-122"/>
                 <a:cs typeface="Arial" pitchFamily="34" charset="-120"/>
               </a:rPr>
-              <a:t>Receipts for everything</a:t>
+              <a:t>Money moving every day</a:t>
             </a:r>
             <a:endParaRPr lang="en-US" sz="1600" dirty="0"/>
           </a:p>
@@ -17825,7 +16954,7 @@
                 <a:ea typeface="Arial" pitchFamily="34" charset="-122"/>
                 <a:cs typeface="Arial" pitchFamily="34" charset="-120"/>
               </a:rPr>
-              <a:t>Every expense, including the owner's, needs a receipt for the government</a:t>
+              <a:t>Payments for materials, workers, machines and site costs at every site, all needing proper records</a:t>
             </a:r>
             <a:endParaRPr lang="en-US" sz="1250" dirty="0"/>
           </a:p>
@@ -17952,7 +17081,7 @@
                 <a:ea typeface="Arial" pitchFamily="34" charset="-122"/>
                 <a:cs typeface="Arial" pitchFamily="34" charset="-120"/>
               </a:rPr>
-              <a:t>Many daily labourers on site, paid against attendance with signed receipts</a:t>
+              <a:t>Many daily labourers on site, paid based on their attendance</a:t>
             </a:r>
             <a:endParaRPr lang="en-US" sz="1250" dirty="0"/>
           </a:p>
@@ -18016,7 +17145,7 @@
                 <a:ea typeface="Arial" pitchFamily="34" charset="-122"/>
                 <a:cs typeface="Arial" pitchFamily="34" charset="-120"/>
               </a:rPr>
-              <a:t>Your 5 departments</a:t>
+              <a:t>The core departments</a:t>
             </a:r>
             <a:endParaRPr lang="en-US" sz="1700" dirty="0"/>
           </a:p>
@@ -18222,7 +17351,7 @@
                 <a:ea typeface="Arial" pitchFamily="34" charset="-122"/>
                 <a:cs typeface="Arial" pitchFamily="34" charset="-120"/>
               </a:rPr>
-              <a:t>Sales group (market prices, buying &amp; selling)</a:t>
+              <a:t>Sales &amp; purchasing (market prices, buying &amp; selling)</a:t>
             </a:r>
             <a:endParaRPr lang="en-US" sz="1350" dirty="0"/>
           </a:p>
@@ -18570,7 +17699,7 @@
                 <a:ea typeface="Arial" pitchFamily="34" charset="-122"/>
                 <a:cs typeface="Arial" pitchFamily="34" charset="-120"/>
               </a:rPr>
-              <a:t>Your goal: </a:t>
+              <a:t>The aim: </a:t>
             </a:r>
             <a:pPr indent="0" marL="0">
               <a:buNone/>
@@ -18584,7 +17713,7 @@
                 <a:ea typeface="Arial" pitchFamily="34" charset="-122"/>
                 <a:cs typeface="Arial" pitchFamily="34" charset="-120"/>
               </a:rPr>
-              <a:t>put the whole business into one system, with nothing left on paper. We researched how construction companies work and added the parts that support these 5 departments.</a:t>
+              <a:t>run the whole company in one system, with nothing left on paper. On top of these core departments, we add the supporting modules every construction company needs.</a:t>
             </a:r>
             <a:endParaRPr lang="en-US" sz="1250" dirty="0"/>
           </a:p>
@@ -22855,7 +21984,7 @@
                 <a:ea typeface="Arial" pitchFamily="34" charset="-122"/>
                 <a:cs typeface="Arial" pitchFamily="34" charset="-120"/>
               </a:rPr>
-              <a:t>Your 5 departments, plus 7 modules we recommend so nothing is left outside the system</a:t>
+              <a:t>5 core departments, plus 7 supporting modules so nothing is left outside the system</a:t>
             </a:r>
             <a:endParaRPr lang="en-US" sz="1400" dirty="0"/>
           </a:p>
@@ -23414,7 +22543,7 @@
                 <a:ea typeface="Arial" pitchFamily="34" charset="-122"/>
                 <a:cs typeface="Arial" pitchFamily="34" charset="-120"/>
               </a:rPr>
-              <a:t>Finance &amp; receipts</a:t>
+              <a:t>Finance</a:t>
             </a:r>
             <a:endParaRPr lang="en-US" sz="1250" dirty="0"/>
           </a:p>
@@ -24846,7 +23975,7 @@
                 <a:ea typeface="Arial" pitchFamily="34" charset="-122"/>
                 <a:cs typeface="Arial" pitchFamily="34" charset="-120"/>
               </a:rPr>
-              <a:t>From your 5 departments</a:t>
+              <a:t>Core departments</a:t>
             </a:r>
             <a:endParaRPr lang="en-US" sz="1150" dirty="0"/>
           </a:p>
@@ -24910,7 +24039,7 @@
                 <a:ea typeface="Arial" pitchFamily="34" charset="-122"/>
                 <a:cs typeface="Arial" pitchFamily="34" charset="-120"/>
               </a:rPr>
-              <a:t>Added by us after research</a:t>
+              <a:t>Supporting modules</a:t>
             </a:r>
             <a:endParaRPr lang="en-US" sz="1150" dirty="0"/>
           </a:p>
@@ -25314,7 +24443,7 @@
                 <a:ea typeface="Arial" pitchFamily="34" charset="-122"/>
                 <a:cs typeface="Arial" pitchFamily="34" charset="-120"/>
               </a:rPr>
-              <a:t>FROM YOUR DEPARTMENTS</a:t>
+              <a:t>CORE MODULE</a:t>
             </a:r>
             <a:endParaRPr lang="en-US" sz="950" dirty="0"/>
           </a:p>
@@ -25653,7 +24782,7 @@
                 <a:ea typeface="Arial" pitchFamily="34" charset="-122"/>
                 <a:cs typeface="Arial" pitchFamily="34" charset="-120"/>
               </a:rPr>
-              <a:t>ADDED BY US</a:t>
+              <a:t>SUPPORTING MODULE</a:t>
             </a:r>
             <a:endParaRPr lang="en-US" sz="950" dirty="0"/>
           </a:p>
@@ -26269,7 +25398,7 @@
                 <a:ea typeface="Arial" pitchFamily="34" charset="-122"/>
                 <a:cs typeface="Arial" pitchFamily="34" charset="-120"/>
               </a:rPr>
-              <a:t>FROM YOUR DEPARTMENTS</a:t>
+              <a:t>CORE MODULE</a:t>
             </a:r>
             <a:endParaRPr lang="en-US" sz="950" dirty="0"/>
           </a:p>
@@ -26608,7 +25737,7 @@
                 <a:ea typeface="Arial" pitchFamily="34" charset="-122"/>
                 <a:cs typeface="Arial" pitchFamily="34" charset="-120"/>
               </a:rPr>
-              <a:t>ADDED BY US</a:t>
+              <a:t>SUPPORTING MODULE</a:t>
             </a:r>
             <a:endParaRPr lang="en-US" sz="950" dirty="0"/>
           </a:p>
@@ -27224,7 +26353,7 @@
                 <a:ea typeface="Arial" pitchFamily="34" charset="-122"/>
                 <a:cs typeface="Arial" pitchFamily="34" charset="-120"/>
               </a:rPr>
-              <a:t>FROM YOUR DEPARTMENTS</a:t>
+              <a:t>CORE MODULE</a:t>
             </a:r>
             <a:endParaRPr lang="en-US" sz="950" dirty="0"/>
           </a:p>
@@ -27563,7 +26692,7 @@
                 <a:ea typeface="Arial" pitchFamily="34" charset="-122"/>
                 <a:cs typeface="Arial" pitchFamily="34" charset="-120"/>
               </a:rPr>
-              <a:t>ADDED BY US</a:t>
+              <a:t>SUPPORTING MODULE</a:t>
             </a:r>
             <a:endParaRPr lang="en-US" sz="950" dirty="0"/>
           </a:p>
@@ -27910,7 +27039,7 @@
                 <a:ea typeface="Arial" pitchFamily="34" charset="-122"/>
                 <a:cs typeface="Arial" pitchFamily="34" charset="-120"/>
               </a:rPr>
-              <a:t>Finance &amp; receipts  +  Client billing</a:t>
+              <a:t>Finance  +  Client billing</a:t>
             </a:r>
             <a:endParaRPr lang="en-US" sz="2800" dirty="0"/>
           </a:p>
@@ -28140,7 +27269,7 @@
                 <a:ea typeface="Arial" pitchFamily="34" charset="-122"/>
                 <a:cs typeface="Arial" pitchFamily="34" charset="-120"/>
               </a:rPr>
-              <a:t>Finance &amp; receipts</a:t>
+              <a:t>Finance</a:t>
             </a:r>
             <a:endParaRPr lang="en-US" sz="1700" dirty="0"/>
           </a:p>
@@ -28179,7 +27308,7 @@
                 <a:ea typeface="Arial" pitchFamily="34" charset="-122"/>
                 <a:cs typeface="Arial" pitchFamily="34" charset="-120"/>
               </a:rPr>
-              <a:t>FROM YOUR DEPARTMENTS</a:t>
+              <a:t>CORE MODULE</a:t>
             </a:r>
             <a:endParaRPr lang="en-US" sz="950" dirty="0"/>
           </a:p>
@@ -28307,7 +27436,7 @@
                 <a:ea typeface="Arial" pitchFamily="34" charset="-122"/>
                 <a:cs typeface="Arial" pitchFamily="34" charset="-120"/>
               </a:rPr>
-              <a:t>Owner's expenses included; alerts for any missing receipt</a:t>
+              <a:t>Alerts for any payment without a receipt</a:t>
             </a:r>
             <a:endParaRPr lang="en-US" sz="1400" dirty="0"/>
           </a:p>
@@ -28518,7 +27647,7 @@
                 <a:ea typeface="Arial" pitchFamily="34" charset="-122"/>
                 <a:cs typeface="Arial" pitchFamily="34" charset="-120"/>
               </a:rPr>
-              <a:t>ADDED BY US</a:t>
+              <a:t>SUPPORTING MODULE</a:t>
             </a:r>
             <a:endParaRPr lang="en-US" sz="950" dirty="0"/>
           </a:p>

</xml_diff>

<commit_message>
Include hosting and domain in both proposals, update pricing and PWA
O-YES: Package 2 now ETB 350,000; hosting and domain listed as included.
Construction: hosting and domain included; web system described as an
installable PWA.

Co-Authored-By: Claude Opus 5.5 <noreply@anthropic.com>
Claude-Session: https://claude.ai/code/session_01JN1xXW5sGZrcbeUUaddYi7
</commit_message>
<xml_diff>
--- a/docs/proposals/Construction_Management_System_Proposal.pptx
+++ b/docs/proposals/Construction_Management_System_Proposal.pptx
@@ -11515,7 +11515,7 @@
                 <a:ea typeface="Arial" pitchFamily="34" charset="-122"/>
                 <a:cs typeface="Arial" pitchFamily="34" charset="-120"/>
               </a:rPr>
-              <a:t>Web system</a:t>
+              <a:t>Web + installable app</a:t>
             </a:r>
             <a:endParaRPr lang="en-US" sz="1600" dirty="0"/>
           </a:p>
@@ -11554,7 +11554,7 @@
                 <a:ea typeface="Arial" pitchFamily="34" charset="-122"/>
                 <a:cs typeface="Arial" pitchFamily="34" charset="-120"/>
               </a:rPr>
-              <a:t>Works in Chrome, Edge or Firefox on any computer, laptop or tablet; nothing to install</a:t>
+              <a:t>Works in any browser on computer, laptop, tablet or phone, and installs like an app (PWA)</a:t>
             </a:r>
             <a:endParaRPr lang="en-US" sz="1250" dirty="0"/>
           </a:p>
@@ -11642,7 +11642,7 @@
                 <a:ea typeface="Arial" pitchFamily="34" charset="-122"/>
                 <a:cs typeface="Arial" pitchFamily="34" charset="-120"/>
               </a:rPr>
-              <a:t>Hosted online</a:t>
+              <a:t>Hosting &amp; domain included</a:t>
             </a:r>
             <a:endParaRPr lang="en-US" sz="1600" dirty="0"/>
           </a:p>
@@ -11681,7 +11681,7 @@
                 <a:ea typeface="Arial" pitchFamily="34" charset="-122"/>
                 <a:cs typeface="Arial" pitchFamily="34" charset="-120"/>
               </a:rPr>
-              <a:t>Cloud server or your own server; accessible from the office and every site</a:t>
+              <a:t>We provide the server and domain; reachable from the office and every site</a:t>
             </a:r>
             <a:endParaRPr lang="en-US" sz="1250" dirty="0"/>
           </a:p>
@@ -12228,7 +12228,7 @@
                 <a:ea typeface="Arial" pitchFamily="34" charset="-122"/>
                 <a:cs typeface="Arial" pitchFamily="34" charset="-120"/>
               </a:rPr>
-              <a:t>Technology: React web application · Node.js server · MySQL database</a:t>
+              <a:t>Technology: React web application (installable PWA) · Node.js server · MySQL database</a:t>
             </a:r>
             <a:endParaRPr lang="en-US" sz="1200" dirty="0"/>
           </a:p>
@@ -14411,7 +14411,7 @@
                 <a:ea typeface="Arial" pitchFamily="34" charset="-122"/>
                 <a:cs typeface="Arial" pitchFamily="34" charset="-120"/>
               </a:rPr>
-              <a:t>Setup on your cloud or office server</a:t>
+              <a:t>Hosting and domain, fully set up</a:t>
             </a:r>
             <a:endParaRPr lang="en-US" sz="1250" dirty="0"/>
           </a:p>
@@ -14581,7 +14581,7 @@
                 <a:ea typeface="Arial" pitchFamily="34" charset="-122"/>
                 <a:cs typeface="Arial" pitchFamily="34" charset="-120"/>
               </a:rPr>
-              <a:t>Server hosting, domain and SMS fees (paid directly to the provider)</a:t>
+              <a:t>SMS fees, if SMS alerts are used</a:t>
             </a:r>
             <a:endParaRPr lang="en-US" sz="1150" dirty="0"/>
           </a:p>

</xml_diff>

<commit_message>
Extend construction proposal timeline to about 2 months
Timeline slide now spans 8 weeks; investment and next-steps slides
updated to match.

Co-Authored-By: Claude Opus 5.5 <noreply@anthropic.com>
Claude-Session: https://claude.ai/code/session_01JN1xXW5sGZrcbeUUaddYi7
</commit_message>
<xml_diff>
--- a/docs/proposals/Construction_Management_System_Proposal.pptx
+++ b/docs/proposals/Construction_Management_System_Proposal.pptx
@@ -1225,7 +1225,7 @@
           <a:p>
             <a:r>
               <a:rPr lang="en-US" dirty="0"/>
-              <a:t>Six weeks is achievable because modules are built in parallel on one shared foundation. Quick answers from the client's side are essential.</a:t>
+              <a:t>Eight weeks is achievable because modules are built in parallel on one shared foundation. Quick answers from the client's side are essential.</a:t>
             </a:r>
             <a:endParaRPr lang="en-US" dirty="0"/>
           </a:p>
@@ -12363,7 +12363,7 @@
                 <a:ea typeface="Arial" pitchFamily="34" charset="-122"/>
                 <a:cs typeface="Arial" pitchFamily="34" charset="-120"/>
               </a:rPr>
-              <a:t>Ready in about 1.5 months</a:t>
+              <a:t>Ready in about 2 months</a:t>
             </a:r>
             <a:endParaRPr lang="en-US" sz="2800" dirty="0"/>
           </a:p>
@@ -12402,7 +12402,7 @@
                 <a:ea typeface="Arial" pitchFamily="34" charset="-122"/>
                 <a:cs typeface="Arial" pitchFamily="34" charset="-120"/>
               </a:rPr>
-              <a:t>Six weeks from the start date, delivered in clear steps</a:t>
+              <a:t>Eight weeks from the start date, delivered in clear steps</a:t>
             </a:r>
             <a:endParaRPr lang="en-US" sz="1400" dirty="0"/>
           </a:p>
@@ -12520,7 +12520,7 @@
         <p:spPr>
           <a:xfrm>
             <a:off x="3566160" y="1920240"/>
-            <a:ext cx="1295400" cy="365760"/>
+            <a:ext cx="960120" cy="365760"/>
           </a:xfrm>
           <a:prstGeom prst="rect">
             <a:avLst/>
@@ -12545,7 +12545,7 @@
         <p:spPr>
           <a:xfrm>
             <a:off x="3566160" y="1920240"/>
-            <a:ext cx="1295400" cy="365760"/>
+            <a:ext cx="960120" cy="365760"/>
           </a:xfrm>
           <a:prstGeom prst="rect">
             <a:avLst/>
@@ -12583,8 +12583,8 @@
         </p:nvSpPr>
         <p:spPr>
           <a:xfrm>
-            <a:off x="4907280" y="1920240"/>
-            <a:ext cx="1295400" cy="365760"/>
+            <a:off x="4572000" y="1920240"/>
+            <a:ext cx="960120" cy="365760"/>
           </a:xfrm>
           <a:prstGeom prst="rect">
             <a:avLst/>
@@ -12608,8 +12608,8 @@
         </p:nvSpPr>
         <p:spPr>
           <a:xfrm>
-            <a:off x="4907280" y="1920240"/>
-            <a:ext cx="1295400" cy="365760"/>
+            <a:off x="4572000" y="1920240"/>
+            <a:ext cx="960120" cy="365760"/>
           </a:xfrm>
           <a:prstGeom prst="rect">
             <a:avLst/>
@@ -12647,8 +12647,8 @@
         </p:nvSpPr>
         <p:spPr>
           <a:xfrm>
-            <a:off x="6248400" y="1920240"/>
-            <a:ext cx="1295400" cy="365760"/>
+            <a:off x="5577840" y="1920240"/>
+            <a:ext cx="960120" cy="365760"/>
           </a:xfrm>
           <a:prstGeom prst="rect">
             <a:avLst/>
@@ -12672,8 +12672,8 @@
         </p:nvSpPr>
         <p:spPr>
           <a:xfrm>
-            <a:off x="6248400" y="1920240"/>
-            <a:ext cx="1295400" cy="365760"/>
+            <a:off x="5577840" y="1920240"/>
+            <a:ext cx="960120" cy="365760"/>
           </a:xfrm>
           <a:prstGeom prst="rect">
             <a:avLst/>
@@ -12711,8 +12711,8 @@
         </p:nvSpPr>
         <p:spPr>
           <a:xfrm>
-            <a:off x="7589520" y="1920240"/>
-            <a:ext cx="1295400" cy="365760"/>
+            <a:off x="6583680" y="1920240"/>
+            <a:ext cx="960120" cy="365760"/>
           </a:xfrm>
           <a:prstGeom prst="rect">
             <a:avLst/>
@@ -12736,8 +12736,8 @@
         </p:nvSpPr>
         <p:spPr>
           <a:xfrm>
-            <a:off x="7589520" y="1920240"/>
-            <a:ext cx="1295400" cy="365760"/>
+            <a:off x="6583680" y="1920240"/>
+            <a:ext cx="960120" cy="365760"/>
           </a:xfrm>
           <a:prstGeom prst="rect">
             <a:avLst/>
@@ -12775,8 +12775,8 @@
         </p:nvSpPr>
         <p:spPr>
           <a:xfrm>
-            <a:off x="8930640" y="1920240"/>
-            <a:ext cx="1295400" cy="365760"/>
+            <a:off x="7589520" y="1920240"/>
+            <a:ext cx="960120" cy="365760"/>
           </a:xfrm>
           <a:prstGeom prst="rect">
             <a:avLst/>
@@ -12800,8 +12800,8 @@
         </p:nvSpPr>
         <p:spPr>
           <a:xfrm>
-            <a:off x="8930640" y="1920240"/>
-            <a:ext cx="1295400" cy="365760"/>
+            <a:off x="7589520" y="1920240"/>
+            <a:ext cx="960120" cy="365760"/>
           </a:xfrm>
           <a:prstGeom prst="rect">
             <a:avLst/>
@@ -12839,8 +12839,8 @@
         </p:nvSpPr>
         <p:spPr>
           <a:xfrm>
-            <a:off x="10271760" y="1920240"/>
-            <a:ext cx="1295400" cy="365760"/>
+            <a:off x="8595360" y="1920240"/>
+            <a:ext cx="960120" cy="365760"/>
           </a:xfrm>
           <a:prstGeom prst="rect">
             <a:avLst/>
@@ -12864,8 +12864,8 @@
         </p:nvSpPr>
         <p:spPr>
           <a:xfrm>
-            <a:off x="10271760" y="1920240"/>
-            <a:ext cx="1295400" cy="365760"/>
+            <a:off x="8595360" y="1920240"/>
+            <a:ext cx="960120" cy="365760"/>
           </a:xfrm>
           <a:prstGeom prst="rect">
             <a:avLst/>
@@ -12897,7 +12897,135 @@
       </p:sp>
       <p:sp>
         <p:nvSpPr>
-          <p:cNvPr id="21" name="Text 19"/>
+          <p:cNvPr id="21" name="Shape 19"/>
+          <p:cNvSpPr/>
+          <p:nvPr/>
+        </p:nvSpPr>
+        <p:spPr>
+          <a:xfrm>
+            <a:off x="9601200" y="1920240"/>
+            <a:ext cx="960120" cy="365760"/>
+          </a:xfrm>
+          <a:prstGeom prst="rect">
+            <a:avLst/>
+          </a:prstGeom>
+          <a:solidFill>
+            <a:srgbClr val="1E2226"/>
+          </a:solidFill>
+          <a:ln w="12700">
+            <a:solidFill>
+              <a:srgbClr val="1E2226"/>
+            </a:solidFill>
+            <a:prstDash val="solid"/>
+          </a:ln>
+        </p:spPr>
+      </p:sp>
+      <p:sp>
+        <p:nvSpPr>
+          <p:cNvPr id="22" name="Text 20"/>
+          <p:cNvSpPr txBox="1"/>
+          <p:nvPr/>
+        </p:nvSpPr>
+        <p:spPr>
+          <a:xfrm>
+            <a:off x="9601200" y="1920240"/>
+            <a:ext cx="960120" cy="365760"/>
+          </a:xfrm>
+          <a:prstGeom prst="rect">
+            <a:avLst/>
+          </a:prstGeom>
+          <a:noFill/>
+          <a:ln/>
+        </p:spPr>
+        <p:txBody>
+          <a:bodyPr wrap="square" lIns="0" tIns="0" rIns="0" bIns="0" rtlCol="0" anchor="ctr"/>
+          <a:lstStyle/>
+          <a:p>
+            <a:pPr algn="ctr" indent="0" marL="0">
+              <a:buNone/>
+            </a:pPr>
+            <a:r>
+              <a:rPr lang="en-US" sz="1100" b="1" dirty="0">
+                <a:solidFill>
+                  <a:srgbClr val="FFFFFF"/>
+                </a:solidFill>
+                <a:latin typeface="Arial" pitchFamily="34" charset="0"/>
+                <a:ea typeface="Arial" pitchFamily="34" charset="-122"/>
+                <a:cs typeface="Arial" pitchFamily="34" charset="-120"/>
+              </a:rPr>
+              <a:t>Week 7</a:t>
+            </a:r>
+            <a:endParaRPr lang="en-US" sz="1100" dirty="0"/>
+          </a:p>
+        </p:txBody>
+      </p:sp>
+      <p:sp>
+        <p:nvSpPr>
+          <p:cNvPr id="23" name="Shape 21"/>
+          <p:cNvSpPr/>
+          <p:nvPr/>
+        </p:nvSpPr>
+        <p:spPr>
+          <a:xfrm>
+            <a:off x="10607040" y="1920240"/>
+            <a:ext cx="960120" cy="365760"/>
+          </a:xfrm>
+          <a:prstGeom prst="rect">
+            <a:avLst/>
+          </a:prstGeom>
+          <a:solidFill>
+            <a:srgbClr val="1E2226"/>
+          </a:solidFill>
+          <a:ln w="12700">
+            <a:solidFill>
+              <a:srgbClr val="1E2226"/>
+            </a:solidFill>
+            <a:prstDash val="solid"/>
+          </a:ln>
+        </p:spPr>
+      </p:sp>
+      <p:sp>
+        <p:nvSpPr>
+          <p:cNvPr id="24" name="Text 22"/>
+          <p:cNvSpPr txBox="1"/>
+          <p:nvPr/>
+        </p:nvSpPr>
+        <p:spPr>
+          <a:xfrm>
+            <a:off x="10607040" y="1920240"/>
+            <a:ext cx="960120" cy="365760"/>
+          </a:xfrm>
+          <a:prstGeom prst="rect">
+            <a:avLst/>
+          </a:prstGeom>
+          <a:noFill/>
+          <a:ln/>
+        </p:spPr>
+        <p:txBody>
+          <a:bodyPr wrap="square" lIns="0" tIns="0" rIns="0" bIns="0" rtlCol="0" anchor="ctr"/>
+          <a:lstStyle/>
+          <a:p>
+            <a:pPr algn="ctr" indent="0" marL="0">
+              <a:buNone/>
+            </a:pPr>
+            <a:r>
+              <a:rPr lang="en-US" sz="1100" b="1" dirty="0">
+                <a:solidFill>
+                  <a:srgbClr val="FFFFFF"/>
+                </a:solidFill>
+                <a:latin typeface="Arial" pitchFamily="34" charset="0"/>
+                <a:ea typeface="Arial" pitchFamily="34" charset="-122"/>
+                <a:cs typeface="Arial" pitchFamily="34" charset="-120"/>
+              </a:rPr>
+              <a:t>Week 8</a:t>
+            </a:r>
+            <a:endParaRPr lang="en-US" sz="1100" dirty="0"/>
+          </a:p>
+        </p:txBody>
+      </p:sp>
+      <p:sp>
+        <p:nvSpPr>
+          <p:cNvPr id="25" name="Text 23"/>
           <p:cNvSpPr txBox="1"/>
           <p:nvPr/>
         </p:nvSpPr>
@@ -12936,7 +13064,7 @@
       </p:sp>
       <p:sp>
         <p:nvSpPr>
-          <p:cNvPr id="22" name="Text 20"/>
+          <p:cNvPr id="26" name="Text 24"/>
           <p:cNvSpPr txBox="1"/>
           <p:nvPr/>
         </p:nvSpPr>
@@ -12975,14 +13103,14 @@
       </p:sp>
       <p:sp>
         <p:nvSpPr>
-          <p:cNvPr id="23" name="Shape 21"/>
+          <p:cNvPr id="27" name="Shape 25"/>
           <p:cNvSpPr/>
           <p:nvPr/>
         </p:nvSpPr>
         <p:spPr>
           <a:xfrm>
             <a:off x="3566160" y="2542032"/>
-            <a:ext cx="1295400" cy="411480"/>
+            <a:ext cx="1463040" cy="411480"/>
           </a:xfrm>
           <a:prstGeom prst="rect">
             <a:avLst/>
@@ -13000,7 +13128,7 @@
       </p:sp>
       <p:sp>
         <p:nvSpPr>
-          <p:cNvPr id="24" name="Text 22"/>
+          <p:cNvPr id="28" name="Text 26"/>
           <p:cNvSpPr txBox="1"/>
           <p:nvPr/>
         </p:nvSpPr>
@@ -13039,7 +13167,7 @@
       </p:sp>
       <p:sp>
         <p:nvSpPr>
-          <p:cNvPr id="25" name="Text 23"/>
+          <p:cNvPr id="29" name="Text 27"/>
           <p:cNvSpPr txBox="1"/>
           <p:nvPr/>
         </p:nvSpPr>
@@ -13078,14 +13206,14 @@
       </p:sp>
       <p:sp>
         <p:nvSpPr>
-          <p:cNvPr id="26" name="Shape 24"/>
+          <p:cNvPr id="30" name="Shape 28"/>
           <p:cNvSpPr/>
           <p:nvPr/>
         </p:nvSpPr>
         <p:spPr>
           <a:xfrm>
-            <a:off x="4907280" y="3127248"/>
-            <a:ext cx="2636520" cy="411480"/>
+            <a:off x="5074920" y="3127248"/>
+            <a:ext cx="2468880" cy="411480"/>
           </a:xfrm>
           <a:prstGeom prst="rect">
             <a:avLst/>
@@ -13103,7 +13231,7 @@
       </p:sp>
       <p:sp>
         <p:nvSpPr>
-          <p:cNvPr id="27" name="Text 25"/>
+          <p:cNvPr id="31" name="Text 29"/>
           <p:cNvSpPr txBox="1"/>
           <p:nvPr/>
         </p:nvSpPr>
@@ -13142,7 +13270,7 @@
       </p:sp>
       <p:sp>
         <p:nvSpPr>
-          <p:cNvPr id="28" name="Text 26"/>
+          <p:cNvPr id="32" name="Text 30"/>
           <p:cNvSpPr txBox="1"/>
           <p:nvPr/>
         </p:nvSpPr>
@@ -13181,14 +13309,14 @@
       </p:sp>
       <p:sp>
         <p:nvSpPr>
-          <p:cNvPr id="29" name="Shape 27"/>
+          <p:cNvPr id="33" name="Shape 31"/>
           <p:cNvSpPr/>
           <p:nvPr/>
         </p:nvSpPr>
         <p:spPr>
           <a:xfrm>
-            <a:off x="6248400" y="3712464"/>
-            <a:ext cx="3307080" cy="411480"/>
+            <a:off x="6583680" y="3712464"/>
+            <a:ext cx="2468880" cy="411480"/>
           </a:xfrm>
           <a:prstGeom prst="rect">
             <a:avLst/>
@@ -13206,7 +13334,7 @@
       </p:sp>
       <p:sp>
         <p:nvSpPr>
-          <p:cNvPr id="30" name="Text 28"/>
+          <p:cNvPr id="34" name="Text 32"/>
           <p:cNvSpPr txBox="1"/>
           <p:nvPr/>
         </p:nvSpPr>
@@ -13245,7 +13373,7 @@
       </p:sp>
       <p:sp>
         <p:nvSpPr>
-          <p:cNvPr id="31" name="Text 29"/>
+          <p:cNvPr id="35" name="Text 33"/>
           <p:cNvSpPr txBox="1"/>
           <p:nvPr/>
         </p:nvSpPr>
@@ -13284,13 +13412,13 @@
       </p:sp>
       <p:sp>
         <p:nvSpPr>
-          <p:cNvPr id="32" name="Shape 30"/>
+          <p:cNvPr id="36" name="Shape 34"/>
           <p:cNvSpPr/>
           <p:nvPr/>
         </p:nvSpPr>
         <p:spPr>
           <a:xfrm>
-            <a:off x="8260080" y="4297680"/>
+            <a:off x="8092440" y="4297680"/>
             <a:ext cx="1965960" cy="411480"/>
           </a:xfrm>
           <a:prstGeom prst="rect">
@@ -13309,7 +13437,7 @@
       </p:sp>
       <p:sp>
         <p:nvSpPr>
-          <p:cNvPr id="33" name="Text 31"/>
+          <p:cNvPr id="37" name="Text 35"/>
           <p:cNvSpPr txBox="1"/>
           <p:nvPr/>
         </p:nvSpPr>
@@ -13348,7 +13476,7 @@
       </p:sp>
       <p:sp>
         <p:nvSpPr>
-          <p:cNvPr id="34" name="Text 32"/>
+          <p:cNvPr id="38" name="Text 36"/>
           <p:cNvSpPr txBox="1"/>
           <p:nvPr/>
         </p:nvSpPr>
@@ -13387,14 +13515,14 @@
       </p:sp>
       <p:sp>
         <p:nvSpPr>
-          <p:cNvPr id="35" name="Shape 33"/>
+          <p:cNvPr id="39" name="Shape 37"/>
           <p:cNvSpPr/>
           <p:nvPr/>
         </p:nvSpPr>
         <p:spPr>
           <a:xfrm>
             <a:off x="9601200" y="4882896"/>
-            <a:ext cx="1295400" cy="411480"/>
+            <a:ext cx="1463040" cy="411480"/>
           </a:xfrm>
           <a:prstGeom prst="rect">
             <a:avLst/>
@@ -13412,7 +13540,7 @@
       </p:sp>
       <p:sp>
         <p:nvSpPr>
-          <p:cNvPr id="36" name="Text 34"/>
+          <p:cNvPr id="40" name="Text 38"/>
           <p:cNvSpPr txBox="1"/>
           <p:nvPr/>
         </p:nvSpPr>
@@ -13451,7 +13579,7 @@
       </p:sp>
       <p:sp>
         <p:nvSpPr>
-          <p:cNvPr id="37" name="Text 35"/>
+          <p:cNvPr id="41" name="Text 39"/>
           <p:cNvSpPr txBox="1"/>
           <p:nvPr/>
         </p:nvSpPr>
@@ -13490,14 +13618,14 @@
       </p:sp>
       <p:sp>
         <p:nvSpPr>
-          <p:cNvPr id="38" name="Shape 36"/>
+          <p:cNvPr id="42" name="Shape 40"/>
           <p:cNvSpPr/>
           <p:nvPr/>
         </p:nvSpPr>
         <p:spPr>
           <a:xfrm>
-            <a:off x="10942320" y="5468112"/>
-            <a:ext cx="624840" cy="411480"/>
+            <a:off x="11109960" y="5468112"/>
+            <a:ext cx="457200" cy="411480"/>
           </a:xfrm>
           <a:prstGeom prst="rect">
             <a:avLst/>
@@ -13515,7 +13643,7 @@
       </p:sp>
       <p:sp>
         <p:nvSpPr>
-          <p:cNvPr id="39" name="Shape 37"/>
+          <p:cNvPr id="43" name="Shape 41"/>
           <p:cNvSpPr/>
           <p:nvPr/>
         </p:nvSpPr>
@@ -13540,7 +13668,7 @@
       </p:sp>
       <p:sp>
         <p:nvSpPr>
-          <p:cNvPr id="40" name="Text 38"/>
+          <p:cNvPr id="44" name="Text 42"/>
           <p:cNvSpPr txBox="1"/>
           <p:nvPr/>
         </p:nvSpPr>
@@ -13745,7 +13873,7 @@
                 <a:ea typeface="Arial" pitchFamily="34" charset="-122"/>
                 <a:cs typeface="Arial" pitchFamily="34" charset="-120"/>
               </a:rPr>
-              <a:t>All 12 modules, web system, delivered in about 1.5 months</a:t>
+              <a:t>All 12 modules, web system, delivered in about 2 months</a:t>
             </a:r>
             <a:endParaRPr lang="en-US" sz="1400" dirty="0"/>
           </a:p>
@@ -18391,7 +18519,7 @@
                 <a:ea typeface="Arial" pitchFamily="34" charset="-122"/>
                 <a:cs typeface="Arial" pitchFamily="34" charset="-120"/>
               </a:rPr>
-              <a:t>About 1.5 months to a working system</a:t>
+              <a:t>About 2 months to a working system</a:t>
             </a:r>
             <a:endParaRPr lang="en-US" sz="1300" dirty="0"/>
           </a:p>

</xml_diff>